<commit_message>
125M packs only: show the other project's finances and the combined cash position (deck slide, memo section 11.2, annex sheet); update QA and internal Q&A
Co-Authored-By: Claude Sonnet 5.5 <noreply@anthropic.com>
Claude-Session: https://claude.ai/code/session_01Tace5U23AKexiDyfCZxMPM
</commit_message>
<xml_diff>
--- a/output/GS_125M/Deck.pptx
+++ b/output/GS_125M/Deck.pptx
@@ -22,9 +22,10 @@
     <p:sldId id="270" r:id="rId16"/>
     <p:sldId id="271" r:id="rId17"/>
     <p:sldId id="272" r:id="rId18"/>
+    <p:sldId id="273" r:id="rId19"/>
   </p:sldIdLst>
   <p:notesMasterIdLst>
-    <p:notesMasterId r:id="rId19"/>
+    <p:notesMasterId r:id="rId20"/>
   </p:notesMasterIdLst>
   <p:sldSz cx="12192000" cy="6858000"/>
   <p:notesSz cx="6858000" cy="12192000"/>
@@ -1864,6 +1865,978 @@
           <a:lstStyle/>
           <a:p>
             <a:pPr>
+              <a:defRPr sz="1200" b="0" i="0" u="none" strike="noStrike">
+                <a:solidFill>
+                  <a:srgbClr val="1B1F2A"/>
+                </a:solidFill>
+                <a:latin typeface="Arial"/>
+              </a:defRPr>
+            </a:pPr>
+            <a:r>
+              <a:rPr sz="1200" b="0" i="0" u="none" strike="noStrike">
+                <a:solidFill>
+                  <a:srgbClr val="1B1F2A"/>
+                </a:solidFill>
+                <a:latin typeface="Arial"/>
+              </a:rPr>
+              <a:t>Cumulative net cash flow before investor instruments (EGP million)</a:t>
+            </a:r>
+          </a:p>
+        </c:rich>
+      </c:tx>
+      <c:layout/>
+      <c:overlay val="0"/>
+    </c:title>
+    <c:autoTitleDeleted val="0"/>
+    <c:plotArea>
+      <c:layout/>
+      <c:lineChart>
+        <c:varyColors val="0"/>
+        <c:ser>
+          <c:idx val="0"/>
+          <c:order val="0"/>
+          <c:tx>
+            <c:strRef>
+              <c:f>Sheet1!$B$1</c:f>
+              <c:strCache>
+                <c:ptCount val="1"/>
+                <c:pt idx="0">
+                  <c:v>Green Square</c:v>
+                </c:pt>
+              </c:strCache>
+            </c:strRef>
+          </c:tx>
+          <c:spPr>
+            <a:solidFill>
+              <a:srgbClr val="17324D"/>
+            </a:solidFill>
+            <a:ln w="31750" cap="flat">
+              <a:solidFill>
+                <a:srgbClr val="17324D"/>
+              </a:solidFill>
+              <a:prstDash val="solid"/>
+              <a:round/>
+            </a:ln>
+            <a:effectLst/>
+          </c:spPr>
+          <c:invertIfNegative val="0"/>
+          <c:dLbls>
+            <c:numFmt formatCode="#,##0" sourceLinked="0"/>
+            <c:txPr>
+              <a:bodyPr/>
+              <a:lstStyle/>
+              <a:p>
+                <a:pPr>
+                  <a:defRPr b="0" i="0" strike="noStrike" sz="1200" u="none">
+                    <a:solidFill>
+                      <a:srgbClr val="000000"/>
+                    </a:solidFill>
+                    <a:latin typeface="Arial"/>
+                  </a:defRPr>
+                </a:pPr>
+              </a:p>
+            </c:txPr>
+            <c:showLegendKey val="0"/>
+            <c:showVal val="0"/>
+            <c:showCatName val="0"/>
+            <c:showSerName val="0"/>
+            <c:showPercent val="0"/>
+            <c:showBubbleSize val="0"/>
+            <c:showLeaderLines val="0"/>
+          </c:dLbls>
+          <c:marker>
+            <c:symbol val="none"/>
+            <c:size val="6"/>
+            <c:spPr>
+              <a:solidFill>
+                <a:srgbClr val="17324D"/>
+              </a:solidFill>
+              <a:ln w="9525" cap="flat">
+                <a:solidFill>
+                  <a:srgbClr val="17324D"/>
+                </a:solidFill>
+                <a:prstDash val="solid"/>
+                <a:round/>
+              </a:ln>
+              <a:effectLst/>
+            </c:spPr>
+          </c:marker>
+          <c:cat>
+            <c:multiLvlStrRef>
+              <c:f>Sheet1!$A$2:$A$29</c:f>
+              <c:multiLvlStrCache>
+                <c:ptCount val="28"/>
+                <c:lvl>
+                  <c:pt idx="0">
+                    <c:v>M3</c:v>
+                  </c:pt>
+                  <c:pt idx="1">
+                    <c:v>M6</c:v>
+                  </c:pt>
+                  <c:pt idx="2">
+                    <c:v>M9</c:v>
+                  </c:pt>
+                  <c:pt idx="3">
+                    <c:v>M12</c:v>
+                  </c:pt>
+                  <c:pt idx="4">
+                    <c:v>M15</c:v>
+                  </c:pt>
+                  <c:pt idx="5">
+                    <c:v>M18</c:v>
+                  </c:pt>
+                  <c:pt idx="6">
+                    <c:v>M21</c:v>
+                  </c:pt>
+                  <c:pt idx="7">
+                    <c:v>M24</c:v>
+                  </c:pt>
+                  <c:pt idx="8">
+                    <c:v>M27</c:v>
+                  </c:pt>
+                  <c:pt idx="9">
+                    <c:v>M30</c:v>
+                  </c:pt>
+                  <c:pt idx="10">
+                    <c:v>M33</c:v>
+                  </c:pt>
+                  <c:pt idx="11">
+                    <c:v>M36</c:v>
+                  </c:pt>
+                  <c:pt idx="12">
+                    <c:v>M39</c:v>
+                  </c:pt>
+                  <c:pt idx="13">
+                    <c:v>M42</c:v>
+                  </c:pt>
+                  <c:pt idx="14">
+                    <c:v>M45</c:v>
+                  </c:pt>
+                  <c:pt idx="15">
+                    <c:v>M48</c:v>
+                  </c:pt>
+                  <c:pt idx="16">
+                    <c:v>M51</c:v>
+                  </c:pt>
+                  <c:pt idx="17">
+                    <c:v>M54</c:v>
+                  </c:pt>
+                  <c:pt idx="18">
+                    <c:v>M57</c:v>
+                  </c:pt>
+                  <c:pt idx="19">
+                    <c:v>M60</c:v>
+                  </c:pt>
+                  <c:pt idx="20">
+                    <c:v>M63</c:v>
+                  </c:pt>
+                  <c:pt idx="21">
+                    <c:v>M66</c:v>
+                  </c:pt>
+                  <c:pt idx="22">
+                    <c:v>M69</c:v>
+                  </c:pt>
+                  <c:pt idx="23">
+                    <c:v>M72</c:v>
+                  </c:pt>
+                  <c:pt idx="24">
+                    <c:v>M75</c:v>
+                  </c:pt>
+                  <c:pt idx="25">
+                    <c:v>M78</c:v>
+                  </c:pt>
+                  <c:pt idx="26">
+                    <c:v>M81</c:v>
+                  </c:pt>
+                  <c:pt idx="27">
+                    <c:v>M84</c:v>
+                  </c:pt>
+                </c:lvl>
+              </c:multiLvlStrCache>
+            </c:multiLvlStrRef>
+          </c:cat>
+          <c:val>
+            <c:numRef>
+              <c:f>Sheet1!$B$2:$B$29</c:f>
+              <c:numCache>
+                <c:formatCode>General</c:formatCode>
+                <c:ptCount val="28"/>
+                <c:pt idx="0">
+                  <c:v>-91.25</c:v>
+                </c:pt>
+                <c:pt idx="1">
+                  <c:v>-102.5</c:v>
+                </c:pt>
+                <c:pt idx="2">
+                  <c:v>-98.61076249999999</c:v>
+                </c:pt>
+                <c:pt idx="3">
+                  <c:v>-79.58228749999999</c:v>
+                </c:pt>
+                <c:pt idx="4">
+                  <c:v>-78.57028125</c:v>
+                </c:pt>
+                <c:pt idx="5">
+                  <c:v>-68.68474375</c:v>
+                </c:pt>
+                <c:pt idx="6">
+                  <c:v>-86.93043374999999</c:v>
+                </c:pt>
+                <c:pt idx="7">
+                  <c:v>-88.42826437499998</c:v>
+                </c:pt>
+                <c:pt idx="8">
+                  <c:v>-81.73067593749997</c:v>
+                </c:pt>
+                <c:pt idx="9">
+                  <c:v>339.89190156250015</c:v>
+                </c:pt>
+                <c:pt idx="10">
+                  <c:v>478.6586415625002</c:v>
+                </c:pt>
+                <c:pt idx="11">
+                  <c:v>608.3816315625002</c:v>
+                </c:pt>
+                <c:pt idx="12">
+                  <c:v>514.9943415625002</c:v>
+                </c:pt>
+                <c:pt idx="13">
+                  <c:v>394.04351031250013</c:v>
+                </c:pt>
+                <c:pt idx="14">
+                  <c:v>222.49267906250014</c:v>
+                </c:pt>
+                <c:pt idx="15">
+                  <c:v>104.32351468750014</c:v>
+                </c:pt>
+                <c:pt idx="16">
+                  <c:v>120.55015437500013</c:v>
+                </c:pt>
+                <c:pt idx="17">
+                  <c:v>135.26287031250013</c:v>
+                </c:pt>
+                <c:pt idx="18">
+                  <c:v>143.98681500000012</c:v>
+                </c:pt>
+                <c:pt idx="19">
+                  <c:v>148.3697596875001</c:v>
+                </c:pt>
+                <c:pt idx="20">
+                  <c:v>175.25270437500012</c:v>
+                </c:pt>
+                <c:pt idx="21">
+                  <c:v>194.85543031250012</c:v>
+                </c:pt>
+                <c:pt idx="22">
+                  <c:v>214.45815625000012</c:v>
+                </c:pt>
+                <c:pt idx="23">
+                  <c:v>234.0608821875001</c:v>
+                </c:pt>
+                <c:pt idx="24">
+                  <c:v>270.3756081250001</c:v>
+                </c:pt>
+                <c:pt idx="25">
+                  <c:v>303.4142356250001</c:v>
+                </c:pt>
+                <c:pt idx="26">
+                  <c:v>332.8444068750001</c:v>
+                </c:pt>
+                <c:pt idx="27">
+                  <c:v>357.9335781250001</c:v>
+                </c:pt>
+              </c:numCache>
+            </c:numRef>
+          </c:val>
+          <c:smooth val="0"/>
+        </c:ser>
+        <c:ser>
+          <c:idx val="1"/>
+          <c:order val="1"/>
+          <c:tx>
+            <c:strRef>
+              <c:f>Sheet1!$C$1</c:f>
+              <c:strCache>
+                <c:ptCount val="1"/>
+                <c:pt idx="0">
+                  <c:v>L'avenir</c:v>
+                </c:pt>
+              </c:strCache>
+            </c:strRef>
+          </c:tx>
+          <c:spPr>
+            <a:solidFill>
+              <a:srgbClr val="B8893B"/>
+            </a:solidFill>
+            <a:ln w="31750" cap="flat">
+              <a:solidFill>
+                <a:srgbClr val="B8893B"/>
+              </a:solidFill>
+              <a:prstDash val="solid"/>
+              <a:round/>
+            </a:ln>
+            <a:effectLst/>
+          </c:spPr>
+          <c:invertIfNegative val="0"/>
+          <c:dLbls>
+            <c:numFmt formatCode="#,##0" sourceLinked="0"/>
+            <c:txPr>
+              <a:bodyPr/>
+              <a:lstStyle/>
+              <a:p>
+                <a:pPr>
+                  <a:defRPr b="0" i="0" strike="noStrike" sz="1200" u="none">
+                    <a:solidFill>
+                      <a:srgbClr val="000000"/>
+                    </a:solidFill>
+                    <a:latin typeface="Arial"/>
+                  </a:defRPr>
+                </a:pPr>
+              </a:p>
+            </c:txPr>
+            <c:showLegendKey val="0"/>
+            <c:showVal val="0"/>
+            <c:showCatName val="0"/>
+            <c:showSerName val="0"/>
+            <c:showPercent val="0"/>
+            <c:showBubbleSize val="0"/>
+            <c:showLeaderLines val="0"/>
+          </c:dLbls>
+          <c:marker>
+            <c:symbol val="none"/>
+            <c:size val="6"/>
+            <c:spPr>
+              <a:solidFill>
+                <a:srgbClr val="B8893B"/>
+              </a:solidFill>
+              <a:ln w="9525" cap="flat">
+                <a:solidFill>
+                  <a:srgbClr val="B8893B"/>
+                </a:solidFill>
+                <a:prstDash val="solid"/>
+                <a:round/>
+              </a:ln>
+              <a:effectLst/>
+            </c:spPr>
+          </c:marker>
+          <c:cat>
+            <c:multiLvlStrRef>
+              <c:f>Sheet1!$A$2:$A$29</c:f>
+              <c:multiLvlStrCache>
+                <c:ptCount val="28"/>
+                <c:lvl>
+                  <c:pt idx="0">
+                    <c:v>M3</c:v>
+                  </c:pt>
+                  <c:pt idx="1">
+                    <c:v>M6</c:v>
+                  </c:pt>
+                  <c:pt idx="2">
+                    <c:v>M9</c:v>
+                  </c:pt>
+                  <c:pt idx="3">
+                    <c:v>M12</c:v>
+                  </c:pt>
+                  <c:pt idx="4">
+                    <c:v>M15</c:v>
+                  </c:pt>
+                  <c:pt idx="5">
+                    <c:v>M18</c:v>
+                  </c:pt>
+                  <c:pt idx="6">
+                    <c:v>M21</c:v>
+                  </c:pt>
+                  <c:pt idx="7">
+                    <c:v>M24</c:v>
+                  </c:pt>
+                  <c:pt idx="8">
+                    <c:v>M27</c:v>
+                  </c:pt>
+                  <c:pt idx="9">
+                    <c:v>M30</c:v>
+                  </c:pt>
+                  <c:pt idx="10">
+                    <c:v>M33</c:v>
+                  </c:pt>
+                  <c:pt idx="11">
+                    <c:v>M36</c:v>
+                  </c:pt>
+                  <c:pt idx="12">
+                    <c:v>M39</c:v>
+                  </c:pt>
+                  <c:pt idx="13">
+                    <c:v>M42</c:v>
+                  </c:pt>
+                  <c:pt idx="14">
+                    <c:v>M45</c:v>
+                  </c:pt>
+                  <c:pt idx="15">
+                    <c:v>M48</c:v>
+                  </c:pt>
+                  <c:pt idx="16">
+                    <c:v>M51</c:v>
+                  </c:pt>
+                  <c:pt idx="17">
+                    <c:v>M54</c:v>
+                  </c:pt>
+                  <c:pt idx="18">
+                    <c:v>M57</c:v>
+                  </c:pt>
+                  <c:pt idx="19">
+                    <c:v>M60</c:v>
+                  </c:pt>
+                  <c:pt idx="20">
+                    <c:v>M63</c:v>
+                  </c:pt>
+                  <c:pt idx="21">
+                    <c:v>M66</c:v>
+                  </c:pt>
+                  <c:pt idx="22">
+                    <c:v>M69</c:v>
+                  </c:pt>
+                  <c:pt idx="23">
+                    <c:v>M72</c:v>
+                  </c:pt>
+                  <c:pt idx="24">
+                    <c:v>M75</c:v>
+                  </c:pt>
+                  <c:pt idx="25">
+                    <c:v>M78</c:v>
+                  </c:pt>
+                  <c:pt idx="26">
+                    <c:v>M81</c:v>
+                  </c:pt>
+                  <c:pt idx="27">
+                    <c:v>M84</c:v>
+                  </c:pt>
+                </c:lvl>
+              </c:multiLvlStrCache>
+            </c:multiLvlStrRef>
+          </c:cat>
+          <c:val>
+            <c:numRef>
+              <c:f>Sheet1!$C$2:$C$29</c:f>
+              <c:numCache>
+                <c:formatCode>General</c:formatCode>
+                <c:ptCount val="28"/>
+                <c:pt idx="0">
+                  <c:v>0</c:v>
+                </c:pt>
+                <c:pt idx="1">
+                  <c:v>0</c:v>
+                </c:pt>
+                <c:pt idx="2">
+                  <c:v>0</c:v>
+                </c:pt>
+                <c:pt idx="3">
+                  <c:v>-85</c:v>
+                </c:pt>
+                <c:pt idx="4">
+                  <c:v>-89.38435</c:v>
+                </c:pt>
+                <c:pt idx="5">
+                  <c:v>-75.65305</c:v>
+                </c:pt>
+                <c:pt idx="6">
+                  <c:v>-62.892224999999996</c:v>
+                </c:pt>
+                <c:pt idx="7">
+                  <c:v>-46.733835</c:v>
+                </c:pt>
+                <c:pt idx="8">
+                  <c:v>-85.13881</c:v>
+                </c:pt>
+                <c:pt idx="9">
+                  <c:v>-102.0180625</c:v>
+                </c:pt>
+                <c:pt idx="10">
+                  <c:v>-100.94194749999998</c:v>
+                </c:pt>
+                <c:pt idx="11">
+                  <c:v>-77.89594749999998</c:v>
+                </c:pt>
+                <c:pt idx="12">
+                  <c:v>-32.897631249999975</c:v>
+                </c:pt>
+                <c:pt idx="13">
+                  <c:v>22.282351250000005</c:v>
+                </c:pt>
+                <c:pt idx="14">
+                  <c:v>503.5783587499998</c:v>
+                </c:pt>
+                <c:pt idx="15">
+                  <c:v>473.4240912499998</c:v>
+                </c:pt>
+                <c:pt idx="16">
+                  <c:v>344.19036374999973</c:v>
+                </c:pt>
+                <c:pt idx="17">
+                  <c:v>245.74703624999967</c:v>
+                </c:pt>
+                <c:pt idx="18">
+                  <c:v>282.54702374999965</c:v>
+                </c:pt>
+                <c:pt idx="19">
+                  <c:v>317.5354462499996</c:v>
+                </c:pt>
+                <c:pt idx="20">
+                  <c:v>372.3149081249996</c:v>
+                </c:pt>
+                <c:pt idx="21">
+                  <c:v>419.9683218749996</c:v>
+                </c:pt>
+                <c:pt idx="22">
+                  <c:v>458.8061981249996</c:v>
+                </c:pt>
+                <c:pt idx="23">
+                  <c:v>487.35244687499954</c:v>
+                </c:pt>
+                <c:pt idx="24">
+                  <c:v>538.3986956249995</c:v>
+                </c:pt>
+                <c:pt idx="25">
+                  <c:v>589.4449443749995</c:v>
+                </c:pt>
+                <c:pt idx="26">
+                  <c:v>640.4911931249995</c:v>
+                </c:pt>
+                <c:pt idx="27">
+                  <c:v>691.5374418749996</c:v>
+                </c:pt>
+              </c:numCache>
+            </c:numRef>
+          </c:val>
+          <c:smooth val="0"/>
+        </c:ser>
+        <c:ser>
+          <c:idx val="2"/>
+          <c:order val="2"/>
+          <c:tx>
+            <c:strRef>
+              <c:f>Sheet1!$D$1</c:f>
+              <c:strCache>
+                <c:ptCount val="1"/>
+                <c:pt idx="0">
+                  <c:v>Combined</c:v>
+                </c:pt>
+              </c:strCache>
+            </c:strRef>
+          </c:tx>
+          <c:spPr>
+            <a:solidFill>
+              <a:srgbClr val="A23B3B"/>
+            </a:solidFill>
+            <a:ln w="31750" cap="flat">
+              <a:solidFill>
+                <a:srgbClr val="A23B3B"/>
+              </a:solidFill>
+              <a:prstDash val="solid"/>
+              <a:round/>
+            </a:ln>
+            <a:effectLst/>
+          </c:spPr>
+          <c:invertIfNegative val="0"/>
+          <c:dLbls>
+            <c:numFmt formatCode="#,##0" sourceLinked="0"/>
+            <c:txPr>
+              <a:bodyPr/>
+              <a:lstStyle/>
+              <a:p>
+                <a:pPr>
+                  <a:defRPr b="0" i="0" strike="noStrike" sz="1200" u="none">
+                    <a:solidFill>
+                      <a:srgbClr val="000000"/>
+                    </a:solidFill>
+                    <a:latin typeface="Arial"/>
+                  </a:defRPr>
+                </a:pPr>
+              </a:p>
+            </c:txPr>
+            <c:showLegendKey val="0"/>
+            <c:showVal val="0"/>
+            <c:showCatName val="0"/>
+            <c:showSerName val="0"/>
+            <c:showPercent val="0"/>
+            <c:showBubbleSize val="0"/>
+            <c:showLeaderLines val="0"/>
+          </c:dLbls>
+          <c:marker>
+            <c:symbol val="none"/>
+            <c:size val="6"/>
+            <c:spPr>
+              <a:solidFill>
+                <a:srgbClr val="A23B3B"/>
+              </a:solidFill>
+              <a:ln w="9525" cap="flat">
+                <a:solidFill>
+                  <a:srgbClr val="A23B3B"/>
+                </a:solidFill>
+                <a:prstDash val="solid"/>
+                <a:round/>
+              </a:ln>
+              <a:effectLst/>
+            </c:spPr>
+          </c:marker>
+          <c:cat>
+            <c:multiLvlStrRef>
+              <c:f>Sheet1!$A$2:$A$29</c:f>
+              <c:multiLvlStrCache>
+                <c:ptCount val="28"/>
+                <c:lvl>
+                  <c:pt idx="0">
+                    <c:v>M3</c:v>
+                  </c:pt>
+                  <c:pt idx="1">
+                    <c:v>M6</c:v>
+                  </c:pt>
+                  <c:pt idx="2">
+                    <c:v>M9</c:v>
+                  </c:pt>
+                  <c:pt idx="3">
+                    <c:v>M12</c:v>
+                  </c:pt>
+                  <c:pt idx="4">
+                    <c:v>M15</c:v>
+                  </c:pt>
+                  <c:pt idx="5">
+                    <c:v>M18</c:v>
+                  </c:pt>
+                  <c:pt idx="6">
+                    <c:v>M21</c:v>
+                  </c:pt>
+                  <c:pt idx="7">
+                    <c:v>M24</c:v>
+                  </c:pt>
+                  <c:pt idx="8">
+                    <c:v>M27</c:v>
+                  </c:pt>
+                  <c:pt idx="9">
+                    <c:v>M30</c:v>
+                  </c:pt>
+                  <c:pt idx="10">
+                    <c:v>M33</c:v>
+                  </c:pt>
+                  <c:pt idx="11">
+                    <c:v>M36</c:v>
+                  </c:pt>
+                  <c:pt idx="12">
+                    <c:v>M39</c:v>
+                  </c:pt>
+                  <c:pt idx="13">
+                    <c:v>M42</c:v>
+                  </c:pt>
+                  <c:pt idx="14">
+                    <c:v>M45</c:v>
+                  </c:pt>
+                  <c:pt idx="15">
+                    <c:v>M48</c:v>
+                  </c:pt>
+                  <c:pt idx="16">
+                    <c:v>M51</c:v>
+                  </c:pt>
+                  <c:pt idx="17">
+                    <c:v>M54</c:v>
+                  </c:pt>
+                  <c:pt idx="18">
+                    <c:v>M57</c:v>
+                  </c:pt>
+                  <c:pt idx="19">
+                    <c:v>M60</c:v>
+                  </c:pt>
+                  <c:pt idx="20">
+                    <c:v>M63</c:v>
+                  </c:pt>
+                  <c:pt idx="21">
+                    <c:v>M66</c:v>
+                  </c:pt>
+                  <c:pt idx="22">
+                    <c:v>M69</c:v>
+                  </c:pt>
+                  <c:pt idx="23">
+                    <c:v>M72</c:v>
+                  </c:pt>
+                  <c:pt idx="24">
+                    <c:v>M75</c:v>
+                  </c:pt>
+                  <c:pt idx="25">
+                    <c:v>M78</c:v>
+                  </c:pt>
+                  <c:pt idx="26">
+                    <c:v>M81</c:v>
+                  </c:pt>
+                  <c:pt idx="27">
+                    <c:v>M84</c:v>
+                  </c:pt>
+                </c:lvl>
+              </c:multiLvlStrCache>
+            </c:multiLvlStrRef>
+          </c:cat>
+          <c:val>
+            <c:numRef>
+              <c:f>Sheet1!$D$2:$D$29</c:f>
+              <c:numCache>
+                <c:formatCode>General</c:formatCode>
+                <c:ptCount val="28"/>
+                <c:pt idx="0">
+                  <c:v>-91.25</c:v>
+                </c:pt>
+                <c:pt idx="1">
+                  <c:v>-102.5</c:v>
+                </c:pt>
+                <c:pt idx="2">
+                  <c:v>-98.61076249999999</c:v>
+                </c:pt>
+                <c:pt idx="3">
+                  <c:v>-164.5822875</c:v>
+                </c:pt>
+                <c:pt idx="4">
+                  <c:v>-167.95463124999998</c:v>
+                </c:pt>
+                <c:pt idx="5">
+                  <c:v>-144.33779375</c:v>
+                </c:pt>
+                <c:pt idx="6">
+                  <c:v>-149.82265875</c:v>
+                </c:pt>
+                <c:pt idx="7">
+                  <c:v>-135.16209937499997</c:v>
+                </c:pt>
+                <c:pt idx="8">
+                  <c:v>-166.86948593749997</c:v>
+                </c:pt>
+                <c:pt idx="9">
+                  <c:v>237.87383906250017</c:v>
+                </c:pt>
+                <c:pt idx="10">
+                  <c:v>377.7166940625002</c:v>
+                </c:pt>
+                <c:pt idx="11">
+                  <c:v>530.4856840625002</c:v>
+                </c:pt>
+                <c:pt idx="12">
+                  <c:v>482.0967103125002</c:v>
+                </c:pt>
+                <c:pt idx="13">
+                  <c:v>416.3258615625001</c:v>
+                </c:pt>
+                <c:pt idx="14">
+                  <c:v>726.0710378125</c:v>
+                </c:pt>
+                <c:pt idx="15">
+                  <c:v>577.7476059374999</c:v>
+                </c:pt>
+                <c:pt idx="16">
+                  <c:v>464.7405181249999</c:v>
+                </c:pt>
+                <c:pt idx="17">
+                  <c:v>381.0099065624998</c:v>
+                </c:pt>
+                <c:pt idx="18">
+                  <c:v>426.53383874999975</c:v>
+                </c:pt>
+                <c:pt idx="19">
+                  <c:v>465.9052059374997</c:v>
+                </c:pt>
+                <c:pt idx="20">
+                  <c:v>547.5676124999998</c:v>
+                </c:pt>
+                <c:pt idx="21">
+                  <c:v>614.8237521874997</c:v>
+                </c:pt>
+                <c:pt idx="22">
+                  <c:v>673.2643543749997</c:v>
+                </c:pt>
+                <c:pt idx="23">
+                  <c:v>721.4133290624997</c:v>
+                </c:pt>
+                <c:pt idx="24">
+                  <c:v>808.7743037499996</c:v>
+                </c:pt>
+                <c:pt idx="25">
+                  <c:v>892.8591799999997</c:v>
+                </c:pt>
+                <c:pt idx="26">
+                  <c:v>973.3355999999997</c:v>
+                </c:pt>
+                <c:pt idx="27">
+                  <c:v>1049.4710199999997</c:v>
+                </c:pt>
+              </c:numCache>
+            </c:numRef>
+          </c:val>
+          <c:smooth val="0"/>
+        </c:ser>
+        <c:dLbls>
+          <c:numFmt formatCode="#,##0" sourceLinked="0"/>
+          <c:txPr>
+            <a:bodyPr/>
+            <a:lstStyle/>
+            <a:p>
+              <a:pPr>
+                <a:defRPr b="0" i="0" strike="noStrike" sz="1200" u="none">
+                  <a:solidFill>
+                    <a:srgbClr val="000000"/>
+                  </a:solidFill>
+                  <a:latin typeface="Arial"/>
+                </a:defRPr>
+              </a:pPr>
+            </a:p>
+          </c:txPr>
+          <c:showLegendKey val="0"/>
+          <c:showVal val="0"/>
+          <c:showCatName val="0"/>
+          <c:showSerName val="0"/>
+          <c:showPercent val="0"/>
+          <c:showBubbleSize val="0"/>
+          <c:showLeaderLines val="0"/>
+        </c:dLbls>
+        <c:marker val="1"/>
+        <c:axId val="2094734554"/>
+        <c:axId val="2094734552"/>
+        <c:axId val="2094734556"/>
+      </c:lineChart>
+      <c:catAx>
+        <c:axId val="2094734554"/>
+        <c:scaling>
+          <c:orientation val="minMax"/>
+        </c:scaling>
+        <c:delete val="0"/>
+        <c:axPos val="b"/>
+        <c:numFmt formatCode="General" sourceLinked="1"/>
+        <c:majorTickMark val="out"/>
+        <c:minorTickMark val="none"/>
+        <c:tickLblPos val="low"/>
+        <c:spPr>
+          <a:ln w="12700" cap="flat">
+            <a:solidFill>
+              <a:srgbClr val="888888"/>
+            </a:solidFill>
+            <a:prstDash val="solid"/>
+            <a:round/>
+          </a:ln>
+        </c:spPr>
+        <c:txPr>
+          <a:bodyPr/>
+          <a:lstStyle/>
+          <a:p>
+            <a:pPr>
+              <a:defRPr sz="900" b="0" i="0" u="none" strike="noStrike">
+                <a:solidFill>
+                  <a:srgbClr val="000000"/>
+                </a:solidFill>
+                <a:latin typeface="Arial"/>
+              </a:defRPr>
+            </a:pPr>
+            <a:endParaRPr lang="en-US"/>
+          </a:p>
+        </c:txPr>
+        <c:crossAx val="2094734552"/>
+        <c:crosses val="autoZero"/>
+        <c:auto val="1"/>
+        <c:lblAlgn val="ctr"/>
+        <c:noMultiLvlLbl val="1"/>
+        <c:tickLblSkip val="3"/>
+      </c:catAx>
+      <c:valAx>
+        <c:axId val="2094734552"/>
+        <c:scaling>
+          <c:orientation val="minMax"/>
+        </c:scaling>
+        <c:delete val="0"/>
+        <c:axPos val="l"/>
+        <c:majorGridlines>
+          <c:spPr>
+            <a:ln w="6350" cap="flat">
+              <a:solidFill>
+                <a:srgbClr val="D5DAE1"/>
+              </a:solidFill>
+              <a:prstDash val="solid"/>
+              <a:round/>
+            </a:ln>
+          </c:spPr>
+        </c:majorGridlines>
+        <c:numFmt formatCode="General" sourceLinked="0"/>
+        <c:majorTickMark val="out"/>
+        <c:minorTickMark val="none"/>
+        <c:tickLblPos val="nextTo"/>
+        <c:spPr>
+          <a:ln w="12700" cap="flat">
+            <a:solidFill>
+              <a:srgbClr val="888888"/>
+            </a:solidFill>
+            <a:prstDash val="solid"/>
+            <a:round/>
+          </a:ln>
+        </c:spPr>
+        <c:txPr>
+          <a:bodyPr/>
+          <a:lstStyle/>
+          <a:p>
+            <a:pPr>
+              <a:defRPr sz="1000" b="0" i="0" u="none" strike="noStrike">
+                <a:solidFill>
+                  <a:srgbClr val="000000"/>
+                </a:solidFill>
+                <a:latin typeface="Arial"/>
+              </a:defRPr>
+            </a:pPr>
+            <a:endParaRPr lang="en-US"/>
+          </a:p>
+        </c:txPr>
+        <c:crossAx val="2094734554"/>
+        <c:crosses val="autoZero"/>
+        <c:crossBetween val="between"/>
+      </c:valAx>
+      <c:spPr>
+        <a:noFill/>
+        <a:ln>
+          <a:noFill/>
+        </a:ln>
+        <a:effectLst/>
+      </c:spPr>
+    </c:plotArea>
+    <c:legend>
+      <c:legendPos val="b"/>
+      <c:overlay val="0"/>
+      <c:txPr>
+        <a:bodyPr/>
+        <a:lstStyle/>
+        <a:p>
+          <a:pPr>
+            <a:defRPr sz="1100">      </a:defRPr>
+          </a:pPr>
+          <a:endParaRPr lang="en-US"/>
+        </a:p>
+      </c:txPr>
+    </c:legend>
+    <c:plotVisOnly val="1"/>
+    <c:dispBlanksAs val="span"/>
+  </c:chart>
+  <c:spPr>
+    <a:noFill/>
+    <a:ln>
+      <a:noFill/>
+    </a:ln>
+    <a:effectLst/>
+  </c:spPr>
+  <c:externalData r:id="rId1">
+    <c:autoUpdate val="0"/>
+  </c:externalData>
+</c:chartSpace>
+</file>
+
+<file path=ppt/charts/chart6.xml><?xml version="1.0" encoding="utf-8"?>
+<c:chartSpace xmlns:c="http://schemas.openxmlformats.org/drawingml/2006/chart" xmlns:a="http://schemas.openxmlformats.org/drawingml/2006/main" xmlns:r="http://schemas.openxmlformats.org/officeDocument/2006/relationships">
+  <c:date1904 val="0"/>
+  <c:roundedCorners val="1"/>
+  <c:chart>
+    <c:title>
+      <c:tx>
+        <c:rich>
+          <a:bodyPr/>
+          <a:lstStyle/>
+          <a:p>
+            <a:pPr>
               <a:defRPr sz="1300" b="0" i="0" u="none" strike="noStrike">
                 <a:solidFill>
                   <a:srgbClr val="1B1F2A"/>
@@ -3226,6 +4199,94 @@
           <a:p>
             <a:r>
               <a:rPr lang="en-US" dirty="0"/>
+              <a:t>Figures are taken from the Financial Annex (Summary sheet). All returns are projections.</a:t>
+            </a:r>
+            <a:endParaRPr lang="en-US" dirty="0"/>
+          </a:p>
+        </p:txBody>
+      </p:sp>
+      <p:sp>
+        <p:nvSpPr>
+          <p:cNvPr id="4" name="Slide Number Placeholder 3"/>
+          <p:cNvSpPr>
+            <a:spLocks noGrp="1"/>
+          </p:cNvSpPr>
+          <p:nvPr>
+            <p:ph type="sldNum" sz="quarter" idx="10"/>
+          </p:nvPr>
+        </p:nvSpPr>
+        <p:spPr/>
+        <p:txBody>
+          <a:bodyPr/>
+          <a:lstStyle/>
+          <a:p>
+            <a:fld id="{F7021451-1387-4CA6-816F-3879F97B5CBC}" type="slidenum">
+              <a:rPr lang="en-US"/>
+              <a:t>17</a:t>
+            </a:fld>
+            <a:endParaRPr lang="en-US"/>
+          </a:p>
+        </p:txBody>
+      </p:sp>
+    </p:spTree>
+    <p:extLst>
+      <p:ext uri="{BB962C8B-B14F-4D97-AF65-F5344CB8AC3E}">
+        <p14:creationId xmlns:p14="http://schemas.microsoft.com/office/powerpoint/2010/main" val="1024086991"/>
+      </p:ext>
+    </p:extLst>
+  </p:cSld>
+  <p:clrMapOvr>
+    <a:masterClrMapping/>
+  </p:clrMapOvr>
+</p:notes>
+</file>
+
+<file path=ppt/notesSlides/notesSlide18.xml><?xml version="1.0" encoding="utf-8"?>
+<p:notes xmlns:a="http://schemas.openxmlformats.org/drawingml/2006/main" xmlns:r="http://schemas.openxmlformats.org/officeDocument/2006/relationships" xmlns:p="http://schemas.openxmlformats.org/presentationml/2006/main">
+  <p:cSld>
+    <p:spTree>
+      <p:nvGrpSpPr>
+        <p:cNvPr id="1" name=""/>
+        <p:cNvGrpSpPr/>
+        <p:nvPr/>
+      </p:nvGrpSpPr>
+      <p:grpSpPr>
+        <a:xfrm>
+          <a:off x="0" y="0"/>
+          <a:ext cx="0" cy="0"/>
+          <a:chOff x="0" y="0"/>
+          <a:chExt cx="0" cy="0"/>
+        </a:xfrm>
+      </p:grpSpPr>
+      <p:sp>
+        <p:nvSpPr>
+          <p:cNvPr id="2" name="Slide Image Placeholder 1"/>
+          <p:cNvSpPr>
+            <a:spLocks noGrp="1" noRot="1" noChangeAspect="1"/>
+          </p:cNvSpPr>
+          <p:nvPr>
+            <p:ph type="sldImg"/>
+          </p:nvPr>
+        </p:nvSpPr>
+        <p:spPr/>
+      </p:sp>
+      <p:sp>
+        <p:nvSpPr>
+          <p:cNvPr id="3" name="Notes Placeholder 2"/>
+          <p:cNvSpPr>
+            <a:spLocks noGrp="1"/>
+          </p:cNvSpPr>
+          <p:nvPr>
+            <p:ph type="body" idx="1"/>
+          </p:nvPr>
+        </p:nvSpPr>
+        <p:spPr/>
+        <p:txBody>
+          <a:bodyPr/>
+          <a:lstStyle/>
+          <a:p>
+            <a:r>
+              <a:rPr lang="en-US" dirty="0"/>
               <a:t>Next steps and contact details to be added by Jalour.</a:t>
             </a:r>
             <a:endParaRPr lang="en-US" dirty="0"/>
@@ -3249,7 +4310,7 @@
           <a:p>
             <a:fld id="{F7021451-1387-4CA6-816F-3879F97B5CBC}" type="slidenum">
               <a:rPr lang="en-US"/>
-              <a:t>17</a:t>
+              <a:t>18</a:t>
             </a:fld>
             <a:endParaRPr lang="en-US"/>
           </a:p>
@@ -5200,6 +6261,2648 @@
                 <a:ea typeface="Cambria" pitchFamily="34" charset="-122"/>
                 <a:cs typeface="Cambria" pitchFamily="34" charset="-120"/>
               </a:rPr>
+              <a:t>Combined cash position: Green Square and L'avenir</a:t>
+            </a:r>
+            <a:endParaRPr lang="en-US" sz="2800" dirty="0"/>
+          </a:p>
+        </p:txBody>
+      </p:sp>
+      <p:graphicFrame>
+        <p:nvGraphicFramePr>
+          <p:cNvPr id="4" name="Chart 0" descr=""/>
+          <p:cNvGraphicFramePr/>
+          <p:nvPr/>
+        </p:nvGraphicFramePr>
+        <p:xfrm>
+          <a:off x="548640" y="1234440"/>
+          <a:ext cx="5852160" cy="3566160"/>
+        </p:xfrm>
+        <a:graphic xmlns:a="http://schemas.openxmlformats.org/drawingml/2006/main">
+          <a:graphicData uri="http://schemas.openxmlformats.org/drawingml/2006/chart">
+            <c:chart xmlns:c="http://schemas.openxmlformats.org/drawingml/2006/chart" r:id="rId1"/>
+          </a:graphicData>
+        </a:graphic>
+      </p:graphicFrame>
+      <p:graphicFrame>
+        <p:nvGraphicFramePr>
+          <p:cNvPr id="12" name="Table 0"/>
+          <p:cNvGraphicFramePr>
+            <a:graphicFrameLocks noGrp="1"/>
+          </p:cNvGraphicFramePr>
+          <p:nvPr>
+            <p:extLst>
+              <p:ext uri="{D42A27DB-BD31-4B8C-83A1-F6EECF244321}">
+                <p14:modId xmlns:p14="http://schemas.microsoft.com/office/powerpoint/2010/main" val="1579011935"/>
+              </p:ext>
+            </p:extLst>
+          </p:nvPr>
+        </p:nvGraphicFramePr>
+        <p:xfrm>
+          <a:off x="6675120" y="1280160"/>
+          <a:ext cx="4937760" cy="914400"/>
+        </p:xfrm>
+        <a:graphic>
+          <a:graphicData uri="http://schemas.openxmlformats.org/drawingml/2006/table">
+            <a:tbl>
+              <a:tblPr/>
+              <a:tblGrid>
+                <a:gridCol w="2194560"/>
+                <a:gridCol w="1371600"/>
+                <a:gridCol w="1371600"/>
+              </a:tblGrid>
+              <a:tr h="292608">
+                <a:tc>
+                  <a:txBody>
+                    <a:bodyPr/>
+                    <a:lstStyle/>
+                    <a:p>
+                      <a:pPr algn="l" indent="0" marL="0">
+                        <a:buNone/>
+                      </a:pPr>
+                      <a:r>
+                        <a:rPr lang="en-US" sz="1100" b="1" dirty="0">
+                          <a:solidFill>
+                            <a:srgbClr val="FFFFFF"/>
+                          </a:solidFill>
+                        </a:rPr>
+                        <a:t>EGP million</a:t>
+                      </a:r>
+                      <a:endParaRPr lang="en-US" sz="1100" dirty="0"/>
+                    </a:p>
+                  </a:txBody>
+                  <a:tcPr marL="73152" marR="73152" marT="36576" marB="36576" anchor="ctr">
+                    <a:lnL w="6350" cap="flat" cmpd="sng" algn="ctr">
+                      <a:solidFill>
+                        <a:srgbClr val="D5DAE1"/>
+                      </a:solidFill>
+                      <a:prstDash val="solid"/>
+                      <a:round/>
+                      <a:headEnd type="none" w="med" len="med"/>
+                      <a:tailEnd type="none" w="med" len="med"/>
+                    </a:lnL>
+                    <a:lnR w="6350" cap="flat" cmpd="sng" algn="ctr">
+                      <a:solidFill>
+                        <a:srgbClr val="D5DAE1"/>
+                      </a:solidFill>
+                      <a:prstDash val="solid"/>
+                      <a:round/>
+                      <a:headEnd type="none" w="med" len="med"/>
+                      <a:tailEnd type="none" w="med" len="med"/>
+                    </a:lnR>
+                    <a:lnT w="6350" cap="flat" cmpd="sng" algn="ctr">
+                      <a:solidFill>
+                        <a:srgbClr val="D5DAE1"/>
+                      </a:solidFill>
+                      <a:prstDash val="solid"/>
+                      <a:round/>
+                      <a:headEnd type="none" w="med" len="med"/>
+                      <a:tailEnd type="none" w="med" len="med"/>
+                    </a:lnT>
+                    <a:lnB w="6350" cap="flat" cmpd="sng" algn="ctr">
+                      <a:solidFill>
+                        <a:srgbClr val="D5DAE1"/>
+                      </a:solidFill>
+                      <a:prstDash val="solid"/>
+                      <a:round/>
+                      <a:headEnd type="none" w="med" len="med"/>
+                      <a:tailEnd type="none" w="med" len="med"/>
+                    </a:lnB>
+                    <a:solidFill>
+                      <a:srgbClr val="17324D"/>
+                    </a:solidFill>
+                  </a:tcPr>
+                </a:tc>
+                <a:tc>
+                  <a:txBody>
+                    <a:bodyPr/>
+                    <a:lstStyle/>
+                    <a:p>
+                      <a:pPr algn="r" indent="0" marL="0">
+                        <a:buNone/>
+                      </a:pPr>
+                      <a:r>
+                        <a:rPr lang="en-US" sz="1100" b="1" dirty="0">
+                          <a:solidFill>
+                            <a:srgbClr val="FFFFFF"/>
+                          </a:solidFill>
+                        </a:rPr>
+                        <a:t>Green Square</a:t>
+                      </a:r>
+                      <a:endParaRPr lang="en-US" sz="1100" dirty="0"/>
+                    </a:p>
+                  </a:txBody>
+                  <a:tcPr marL="73152" marR="73152" marT="36576" marB="36576" anchor="ctr">
+                    <a:lnL w="6350" cap="flat" cmpd="sng" algn="ctr">
+                      <a:solidFill>
+                        <a:srgbClr val="D5DAE1"/>
+                      </a:solidFill>
+                      <a:prstDash val="solid"/>
+                      <a:round/>
+                      <a:headEnd type="none" w="med" len="med"/>
+                      <a:tailEnd type="none" w="med" len="med"/>
+                    </a:lnL>
+                    <a:lnR w="6350" cap="flat" cmpd="sng" algn="ctr">
+                      <a:solidFill>
+                        <a:srgbClr val="D5DAE1"/>
+                      </a:solidFill>
+                      <a:prstDash val="solid"/>
+                      <a:round/>
+                      <a:headEnd type="none" w="med" len="med"/>
+                      <a:tailEnd type="none" w="med" len="med"/>
+                    </a:lnR>
+                    <a:lnT w="6350" cap="flat" cmpd="sng" algn="ctr">
+                      <a:solidFill>
+                        <a:srgbClr val="D5DAE1"/>
+                      </a:solidFill>
+                      <a:prstDash val="solid"/>
+                      <a:round/>
+                      <a:headEnd type="none" w="med" len="med"/>
+                      <a:tailEnd type="none" w="med" len="med"/>
+                    </a:lnT>
+                    <a:lnB w="6350" cap="flat" cmpd="sng" algn="ctr">
+                      <a:solidFill>
+                        <a:srgbClr val="D5DAE1"/>
+                      </a:solidFill>
+                      <a:prstDash val="solid"/>
+                      <a:round/>
+                      <a:headEnd type="none" w="med" len="med"/>
+                      <a:tailEnd type="none" w="med" len="med"/>
+                    </a:lnB>
+                    <a:solidFill>
+                      <a:srgbClr val="17324D"/>
+                    </a:solidFill>
+                  </a:tcPr>
+                </a:tc>
+                <a:tc>
+                  <a:txBody>
+                    <a:bodyPr/>
+                    <a:lstStyle/>
+                    <a:p>
+                      <a:pPr algn="r" indent="0" marL="0">
+                        <a:buNone/>
+                      </a:pPr>
+                      <a:r>
+                        <a:rPr lang="en-US" sz="1100" b="1" dirty="0">
+                          <a:solidFill>
+                            <a:srgbClr val="FFFFFF"/>
+                          </a:solidFill>
+                        </a:rPr>
+                        <a:t>L'avenir</a:t>
+                      </a:r>
+                      <a:endParaRPr lang="en-US" sz="1100" dirty="0"/>
+                    </a:p>
+                  </a:txBody>
+                  <a:tcPr marL="73152" marR="73152" marT="36576" marB="36576" anchor="ctr">
+                    <a:lnL w="6350" cap="flat" cmpd="sng" algn="ctr">
+                      <a:solidFill>
+                        <a:srgbClr val="D5DAE1"/>
+                      </a:solidFill>
+                      <a:prstDash val="solid"/>
+                      <a:round/>
+                      <a:headEnd type="none" w="med" len="med"/>
+                      <a:tailEnd type="none" w="med" len="med"/>
+                    </a:lnL>
+                    <a:lnR w="6350" cap="flat" cmpd="sng" algn="ctr">
+                      <a:solidFill>
+                        <a:srgbClr val="D5DAE1"/>
+                      </a:solidFill>
+                      <a:prstDash val="solid"/>
+                      <a:round/>
+                      <a:headEnd type="none" w="med" len="med"/>
+                      <a:tailEnd type="none" w="med" len="med"/>
+                    </a:lnR>
+                    <a:lnT w="6350" cap="flat" cmpd="sng" algn="ctr">
+                      <a:solidFill>
+                        <a:srgbClr val="D5DAE1"/>
+                      </a:solidFill>
+                      <a:prstDash val="solid"/>
+                      <a:round/>
+                      <a:headEnd type="none" w="med" len="med"/>
+                      <a:tailEnd type="none" w="med" len="med"/>
+                    </a:lnT>
+                    <a:lnB w="6350" cap="flat" cmpd="sng" algn="ctr">
+                      <a:solidFill>
+                        <a:srgbClr val="D5DAE1"/>
+                      </a:solidFill>
+                      <a:prstDash val="solid"/>
+                      <a:round/>
+                      <a:headEnd type="none" w="med" len="med"/>
+                      <a:tailEnd type="none" w="med" len="med"/>
+                    </a:lnB>
+                    <a:solidFill>
+                      <a:srgbClr val="17324D"/>
+                    </a:solidFill>
+                  </a:tcPr>
+                </a:tc>
+              </a:tr>
+              <a:tr h="292608">
+                <a:tc>
+                  <a:txBody>
+                    <a:bodyPr/>
+                    <a:lstStyle/>
+                    <a:p>
+                      <a:pPr algn="l" indent="0" marL="0">
+                        <a:buNone/>
+                      </a:pPr>
+                      <a:r>
+                        <a:rPr lang="en-US" sz="1100" dirty="0">
+                          <a:solidFill>
+                            <a:srgbClr val="1B1F2A"/>
+                          </a:solidFill>
+                        </a:rPr>
+                        <a:t>Handover (month)</a:t>
+                      </a:r>
+                      <a:endParaRPr lang="en-US" sz="1100" dirty="0"/>
+                    </a:p>
+                  </a:txBody>
+                  <a:tcPr marL="73152" marR="73152" marT="36576" marB="36576" anchor="ctr">
+                    <a:lnL w="6350" cap="flat" cmpd="sng" algn="ctr">
+                      <a:solidFill>
+                        <a:srgbClr val="D5DAE1"/>
+                      </a:solidFill>
+                      <a:prstDash val="solid"/>
+                      <a:round/>
+                      <a:headEnd type="none" w="med" len="med"/>
+                      <a:tailEnd type="none" w="med" len="med"/>
+                    </a:lnL>
+                    <a:lnR w="6350" cap="flat" cmpd="sng" algn="ctr">
+                      <a:solidFill>
+                        <a:srgbClr val="D5DAE1"/>
+                      </a:solidFill>
+                      <a:prstDash val="solid"/>
+                      <a:round/>
+                      <a:headEnd type="none" w="med" len="med"/>
+                      <a:tailEnd type="none" w="med" len="med"/>
+                    </a:lnR>
+                    <a:lnT w="6350" cap="flat" cmpd="sng" algn="ctr">
+                      <a:solidFill>
+                        <a:srgbClr val="D5DAE1"/>
+                      </a:solidFill>
+                      <a:prstDash val="solid"/>
+                      <a:round/>
+                      <a:headEnd type="none" w="med" len="med"/>
+                      <a:tailEnd type="none" w="med" len="med"/>
+                    </a:lnT>
+                    <a:lnB w="6350" cap="flat" cmpd="sng" algn="ctr">
+                      <a:solidFill>
+                        <a:srgbClr val="D5DAE1"/>
+                      </a:solidFill>
+                      <a:prstDash val="solid"/>
+                      <a:round/>
+                      <a:headEnd type="none" w="med" len="med"/>
+                      <a:tailEnd type="none" w="med" len="med"/>
+                    </a:lnB>
+                    <a:solidFill>
+                      <a:srgbClr val="FFFFFF"/>
+                    </a:solidFill>
+                  </a:tcPr>
+                </a:tc>
+                <a:tc>
+                  <a:txBody>
+                    <a:bodyPr/>
+                    <a:lstStyle/>
+                    <a:p>
+                      <a:pPr algn="r" indent="0" marL="0">
+                        <a:buNone/>
+                      </a:pPr>
+                      <a:r>
+                        <a:rPr lang="en-US" sz="1100" dirty="0">
+                          <a:solidFill>
+                            <a:srgbClr val="1B1F2A"/>
+                          </a:solidFill>
+                        </a:rPr>
+                        <a:t>48</a:t>
+                      </a:r>
+                      <a:endParaRPr lang="en-US" sz="1100" dirty="0"/>
+                    </a:p>
+                  </a:txBody>
+                  <a:tcPr marL="73152" marR="73152" marT="36576" marB="36576" anchor="ctr">
+                    <a:lnL w="6350" cap="flat" cmpd="sng" algn="ctr">
+                      <a:solidFill>
+                        <a:srgbClr val="D5DAE1"/>
+                      </a:solidFill>
+                      <a:prstDash val="solid"/>
+                      <a:round/>
+                      <a:headEnd type="none" w="med" len="med"/>
+                      <a:tailEnd type="none" w="med" len="med"/>
+                    </a:lnL>
+                    <a:lnR w="6350" cap="flat" cmpd="sng" algn="ctr">
+                      <a:solidFill>
+                        <a:srgbClr val="D5DAE1"/>
+                      </a:solidFill>
+                      <a:prstDash val="solid"/>
+                      <a:round/>
+                      <a:headEnd type="none" w="med" len="med"/>
+                      <a:tailEnd type="none" w="med" len="med"/>
+                    </a:lnR>
+                    <a:lnT w="6350" cap="flat" cmpd="sng" algn="ctr">
+                      <a:solidFill>
+                        <a:srgbClr val="D5DAE1"/>
+                      </a:solidFill>
+                      <a:prstDash val="solid"/>
+                      <a:round/>
+                      <a:headEnd type="none" w="med" len="med"/>
+                      <a:tailEnd type="none" w="med" len="med"/>
+                    </a:lnT>
+                    <a:lnB w="6350" cap="flat" cmpd="sng" algn="ctr">
+                      <a:solidFill>
+                        <a:srgbClr val="D5DAE1"/>
+                      </a:solidFill>
+                      <a:prstDash val="solid"/>
+                      <a:round/>
+                      <a:headEnd type="none" w="med" len="med"/>
+                      <a:tailEnd type="none" w="med" len="med"/>
+                    </a:lnB>
+                    <a:solidFill>
+                      <a:srgbClr val="FFFFFF"/>
+                    </a:solidFill>
+                  </a:tcPr>
+                </a:tc>
+                <a:tc>
+                  <a:txBody>
+                    <a:bodyPr/>
+                    <a:lstStyle/>
+                    <a:p>
+                      <a:pPr algn="r" indent="0" marL="0">
+                        <a:buNone/>
+                      </a:pPr>
+                      <a:r>
+                        <a:rPr lang="en-US" sz="1100" dirty="0">
+                          <a:solidFill>
+                            <a:srgbClr val="1B1F2A"/>
+                          </a:solidFill>
+                        </a:rPr>
+                        <a:t>54</a:t>
+                      </a:r>
+                      <a:endParaRPr lang="en-US" sz="1100" dirty="0"/>
+                    </a:p>
+                  </a:txBody>
+                  <a:tcPr marL="73152" marR="73152" marT="36576" marB="36576" anchor="ctr">
+                    <a:lnL w="6350" cap="flat" cmpd="sng" algn="ctr">
+                      <a:solidFill>
+                        <a:srgbClr val="D5DAE1"/>
+                      </a:solidFill>
+                      <a:prstDash val="solid"/>
+                      <a:round/>
+                      <a:headEnd type="none" w="med" len="med"/>
+                      <a:tailEnd type="none" w="med" len="med"/>
+                    </a:lnL>
+                    <a:lnR w="6350" cap="flat" cmpd="sng" algn="ctr">
+                      <a:solidFill>
+                        <a:srgbClr val="D5DAE1"/>
+                      </a:solidFill>
+                      <a:prstDash val="solid"/>
+                      <a:round/>
+                      <a:headEnd type="none" w="med" len="med"/>
+                      <a:tailEnd type="none" w="med" len="med"/>
+                    </a:lnR>
+                    <a:lnT w="6350" cap="flat" cmpd="sng" algn="ctr">
+                      <a:solidFill>
+                        <a:srgbClr val="D5DAE1"/>
+                      </a:solidFill>
+                      <a:prstDash val="solid"/>
+                      <a:round/>
+                      <a:headEnd type="none" w="med" len="med"/>
+                      <a:tailEnd type="none" w="med" len="med"/>
+                    </a:lnT>
+                    <a:lnB w="6350" cap="flat" cmpd="sng" algn="ctr">
+                      <a:solidFill>
+                        <a:srgbClr val="D5DAE1"/>
+                      </a:solidFill>
+                      <a:prstDash val="solid"/>
+                      <a:round/>
+                      <a:headEnd type="none" w="med" len="med"/>
+                      <a:tailEnd type="none" w="med" len="med"/>
+                    </a:lnB>
+                    <a:solidFill>
+                      <a:srgbClr val="FFFFFF"/>
+                    </a:solidFill>
+                  </a:tcPr>
+                </a:tc>
+              </a:tr>
+              <a:tr h="292608">
+                <a:tc>
+                  <a:txBody>
+                    <a:bodyPr/>
+                    <a:lstStyle/>
+                    <a:p>
+                      <a:pPr algn="l" indent="0" marL="0">
+                        <a:buNone/>
+                      </a:pPr>
+                      <a:r>
+                        <a:rPr lang="en-US" sz="1100" dirty="0">
+                          <a:solidFill>
+                            <a:srgbClr val="1B1F2A"/>
+                          </a:solidFill>
+                        </a:rPr>
+                        <a:t>Sales plan, 80% of units</a:t>
+                      </a:r>
+                      <a:endParaRPr lang="en-US" sz="1100" dirty="0"/>
+                    </a:p>
+                  </a:txBody>
+                  <a:tcPr marL="73152" marR="73152" marT="36576" marB="36576" anchor="ctr">
+                    <a:lnL w="6350" cap="flat" cmpd="sng" algn="ctr">
+                      <a:solidFill>
+                        <a:srgbClr val="D5DAE1"/>
+                      </a:solidFill>
+                      <a:prstDash val="solid"/>
+                      <a:round/>
+                      <a:headEnd type="none" w="med" len="med"/>
+                      <a:tailEnd type="none" w="med" len="med"/>
+                    </a:lnL>
+                    <a:lnR w="6350" cap="flat" cmpd="sng" algn="ctr">
+                      <a:solidFill>
+                        <a:srgbClr val="D5DAE1"/>
+                      </a:solidFill>
+                      <a:prstDash val="solid"/>
+                      <a:round/>
+                      <a:headEnd type="none" w="med" len="med"/>
+                      <a:tailEnd type="none" w="med" len="med"/>
+                    </a:lnR>
+                    <a:lnT w="6350" cap="flat" cmpd="sng" algn="ctr">
+                      <a:solidFill>
+                        <a:srgbClr val="D5DAE1"/>
+                      </a:solidFill>
+                      <a:prstDash val="solid"/>
+                      <a:round/>
+                      <a:headEnd type="none" w="med" len="med"/>
+                      <a:tailEnd type="none" w="med" len="med"/>
+                    </a:lnT>
+                    <a:lnB w="6350" cap="flat" cmpd="sng" algn="ctr">
+                      <a:solidFill>
+                        <a:srgbClr val="D5DAE1"/>
+                      </a:solidFill>
+                      <a:prstDash val="solid"/>
+                      <a:round/>
+                      <a:headEnd type="none" w="med" len="med"/>
+                      <a:tailEnd type="none" w="med" len="med"/>
+                    </a:lnB>
+                    <a:solidFill>
+                      <a:srgbClr val="F2F4F7"/>
+                    </a:solidFill>
+                  </a:tcPr>
+                </a:tc>
+                <a:tc>
+                  <a:txBody>
+                    <a:bodyPr/>
+                    <a:lstStyle/>
+                    <a:p>
+                      <a:pPr algn="r" indent="0" marL="0">
+                        <a:buNone/>
+                      </a:pPr>
+                      <a:r>
+                        <a:rPr lang="en-US" sz="1100" dirty="0">
+                          <a:solidFill>
+                            <a:srgbClr val="1B1F2A"/>
+                          </a:solidFill>
+                        </a:rPr>
+                        <a:t>2,253</a:t>
+                      </a:r>
+                      <a:endParaRPr lang="en-US" sz="1100" dirty="0"/>
+                    </a:p>
+                  </a:txBody>
+                  <a:tcPr marL="73152" marR="73152" marT="36576" marB="36576" anchor="ctr">
+                    <a:lnL w="6350" cap="flat" cmpd="sng" algn="ctr">
+                      <a:solidFill>
+                        <a:srgbClr val="D5DAE1"/>
+                      </a:solidFill>
+                      <a:prstDash val="solid"/>
+                      <a:round/>
+                      <a:headEnd type="none" w="med" len="med"/>
+                      <a:tailEnd type="none" w="med" len="med"/>
+                    </a:lnL>
+                    <a:lnR w="6350" cap="flat" cmpd="sng" algn="ctr">
+                      <a:solidFill>
+                        <a:srgbClr val="D5DAE1"/>
+                      </a:solidFill>
+                      <a:prstDash val="solid"/>
+                      <a:round/>
+                      <a:headEnd type="none" w="med" len="med"/>
+                      <a:tailEnd type="none" w="med" len="med"/>
+                    </a:lnR>
+                    <a:lnT w="6350" cap="flat" cmpd="sng" algn="ctr">
+                      <a:solidFill>
+                        <a:srgbClr val="D5DAE1"/>
+                      </a:solidFill>
+                      <a:prstDash val="solid"/>
+                      <a:round/>
+                      <a:headEnd type="none" w="med" len="med"/>
+                      <a:tailEnd type="none" w="med" len="med"/>
+                    </a:lnT>
+                    <a:lnB w="6350" cap="flat" cmpd="sng" algn="ctr">
+                      <a:solidFill>
+                        <a:srgbClr val="D5DAE1"/>
+                      </a:solidFill>
+                      <a:prstDash val="solid"/>
+                      <a:round/>
+                      <a:headEnd type="none" w="med" len="med"/>
+                      <a:tailEnd type="none" w="med" len="med"/>
+                    </a:lnB>
+                    <a:solidFill>
+                      <a:srgbClr val="F2F4F7"/>
+                    </a:solidFill>
+                  </a:tcPr>
+                </a:tc>
+                <a:tc>
+                  <a:txBody>
+                    <a:bodyPr/>
+                    <a:lstStyle/>
+                    <a:p>
+                      <a:pPr algn="r" indent="0" marL="0">
+                        <a:buNone/>
+                      </a:pPr>
+                      <a:r>
+                        <a:rPr lang="en-US" sz="1100" dirty="0">
+                          <a:solidFill>
+                            <a:srgbClr val="1B1F2A"/>
+                          </a:solidFill>
+                        </a:rPr>
+                        <a:t>2,674</a:t>
+                      </a:r>
+                      <a:endParaRPr lang="en-US" sz="1100" dirty="0"/>
+                    </a:p>
+                  </a:txBody>
+                  <a:tcPr marL="73152" marR="73152" marT="36576" marB="36576" anchor="ctr">
+                    <a:lnL w="6350" cap="flat" cmpd="sng" algn="ctr">
+                      <a:solidFill>
+                        <a:srgbClr val="D5DAE1"/>
+                      </a:solidFill>
+                      <a:prstDash val="solid"/>
+                      <a:round/>
+                      <a:headEnd type="none" w="med" len="med"/>
+                      <a:tailEnd type="none" w="med" len="med"/>
+                    </a:lnL>
+                    <a:lnR w="6350" cap="flat" cmpd="sng" algn="ctr">
+                      <a:solidFill>
+                        <a:srgbClr val="D5DAE1"/>
+                      </a:solidFill>
+                      <a:prstDash val="solid"/>
+                      <a:round/>
+                      <a:headEnd type="none" w="med" len="med"/>
+                      <a:tailEnd type="none" w="med" len="med"/>
+                    </a:lnR>
+                    <a:lnT w="6350" cap="flat" cmpd="sng" algn="ctr">
+                      <a:solidFill>
+                        <a:srgbClr val="D5DAE1"/>
+                      </a:solidFill>
+                      <a:prstDash val="solid"/>
+                      <a:round/>
+                      <a:headEnd type="none" w="med" len="med"/>
+                      <a:tailEnd type="none" w="med" len="med"/>
+                    </a:lnT>
+                    <a:lnB w="6350" cap="flat" cmpd="sng" algn="ctr">
+                      <a:solidFill>
+                        <a:srgbClr val="D5DAE1"/>
+                      </a:solidFill>
+                      <a:prstDash val="solid"/>
+                      <a:round/>
+                      <a:headEnd type="none" w="med" len="med"/>
+                      <a:tailEnd type="none" w="med" len="med"/>
+                    </a:lnB>
+                    <a:solidFill>
+                      <a:srgbClr val="F2F4F7"/>
+                    </a:solidFill>
+                  </a:tcPr>
+                </a:tc>
+              </a:tr>
+              <a:tr h="292608">
+                <a:tc>
+                  <a:txBody>
+                    <a:bodyPr/>
+                    <a:lstStyle/>
+                    <a:p>
+                      <a:pPr algn="l" indent="0" marL="0">
+                        <a:buNone/>
+                      </a:pPr>
+                      <a:r>
+                        <a:rPr lang="en-US" sz="1100" dirty="0">
+                          <a:solidFill>
+                            <a:srgbClr val="1B1F2A"/>
+                          </a:solidFill>
+                        </a:rPr>
+                        <a:t>Net cash flow</a:t>
+                      </a:r>
+                      <a:endParaRPr lang="en-US" sz="1100" dirty="0"/>
+                    </a:p>
+                  </a:txBody>
+                  <a:tcPr marL="73152" marR="73152" marT="36576" marB="36576" anchor="ctr">
+                    <a:lnL w="6350" cap="flat" cmpd="sng" algn="ctr">
+                      <a:solidFill>
+                        <a:srgbClr val="D5DAE1"/>
+                      </a:solidFill>
+                      <a:prstDash val="solid"/>
+                      <a:round/>
+                      <a:headEnd type="none" w="med" len="med"/>
+                      <a:tailEnd type="none" w="med" len="med"/>
+                    </a:lnL>
+                    <a:lnR w="6350" cap="flat" cmpd="sng" algn="ctr">
+                      <a:solidFill>
+                        <a:srgbClr val="D5DAE1"/>
+                      </a:solidFill>
+                      <a:prstDash val="solid"/>
+                      <a:round/>
+                      <a:headEnd type="none" w="med" len="med"/>
+                      <a:tailEnd type="none" w="med" len="med"/>
+                    </a:lnR>
+                    <a:lnT w="6350" cap="flat" cmpd="sng" algn="ctr">
+                      <a:solidFill>
+                        <a:srgbClr val="D5DAE1"/>
+                      </a:solidFill>
+                      <a:prstDash val="solid"/>
+                      <a:round/>
+                      <a:headEnd type="none" w="med" len="med"/>
+                      <a:tailEnd type="none" w="med" len="med"/>
+                    </a:lnT>
+                    <a:lnB w="6350" cap="flat" cmpd="sng" algn="ctr">
+                      <a:solidFill>
+                        <a:srgbClr val="D5DAE1"/>
+                      </a:solidFill>
+                      <a:prstDash val="solid"/>
+                      <a:round/>
+                      <a:headEnd type="none" w="med" len="med"/>
+                      <a:tailEnd type="none" w="med" len="med"/>
+                    </a:lnB>
+                    <a:solidFill>
+                      <a:srgbClr val="FFFFFF"/>
+                    </a:solidFill>
+                  </a:tcPr>
+                </a:tc>
+                <a:tc>
+                  <a:txBody>
+                    <a:bodyPr/>
+                    <a:lstStyle/>
+                    <a:p>
+                      <a:pPr algn="r" indent="0" marL="0">
+                        <a:buNone/>
+                      </a:pPr>
+                      <a:r>
+                        <a:rPr lang="en-US" sz="1100" dirty="0">
+                          <a:solidFill>
+                            <a:srgbClr val="1B1F2A"/>
+                          </a:solidFill>
+                        </a:rPr>
+                        <a:t>375</a:t>
+                      </a:r>
+                      <a:endParaRPr lang="en-US" sz="1100" dirty="0"/>
+                    </a:p>
+                  </a:txBody>
+                  <a:tcPr marL="73152" marR="73152" marT="36576" marB="36576" anchor="ctr">
+                    <a:lnL w="6350" cap="flat" cmpd="sng" algn="ctr">
+                      <a:solidFill>
+                        <a:srgbClr val="D5DAE1"/>
+                      </a:solidFill>
+                      <a:prstDash val="solid"/>
+                      <a:round/>
+                      <a:headEnd type="none" w="med" len="med"/>
+                      <a:tailEnd type="none" w="med" len="med"/>
+                    </a:lnL>
+                    <a:lnR w="6350" cap="flat" cmpd="sng" algn="ctr">
+                      <a:solidFill>
+                        <a:srgbClr val="D5DAE1"/>
+                      </a:solidFill>
+                      <a:prstDash val="solid"/>
+                      <a:round/>
+                      <a:headEnd type="none" w="med" len="med"/>
+                      <a:tailEnd type="none" w="med" len="med"/>
+                    </a:lnR>
+                    <a:lnT w="6350" cap="flat" cmpd="sng" algn="ctr">
+                      <a:solidFill>
+                        <a:srgbClr val="D5DAE1"/>
+                      </a:solidFill>
+                      <a:prstDash val="solid"/>
+                      <a:round/>
+                      <a:headEnd type="none" w="med" len="med"/>
+                      <a:tailEnd type="none" w="med" len="med"/>
+                    </a:lnT>
+                    <a:lnB w="6350" cap="flat" cmpd="sng" algn="ctr">
+                      <a:solidFill>
+                        <a:srgbClr val="D5DAE1"/>
+                      </a:solidFill>
+                      <a:prstDash val="solid"/>
+                      <a:round/>
+                      <a:headEnd type="none" w="med" len="med"/>
+                      <a:tailEnd type="none" w="med" len="med"/>
+                    </a:lnB>
+                    <a:solidFill>
+                      <a:srgbClr val="FFFFFF"/>
+                    </a:solidFill>
+                  </a:tcPr>
+                </a:tc>
+                <a:tc>
+                  <a:txBody>
+                    <a:bodyPr/>
+                    <a:lstStyle/>
+                    <a:p>
+                      <a:pPr algn="r" indent="0" marL="0">
+                        <a:buNone/>
+                      </a:pPr>
+                      <a:r>
+                        <a:rPr lang="en-US" sz="1100" dirty="0">
+                          <a:solidFill>
+                            <a:srgbClr val="1B1F2A"/>
+                          </a:solidFill>
+                        </a:rPr>
+                        <a:t>595</a:t>
+                      </a:r>
+                      <a:endParaRPr lang="en-US" sz="1100" dirty="0"/>
+                    </a:p>
+                  </a:txBody>
+                  <a:tcPr marL="73152" marR="73152" marT="36576" marB="36576" anchor="ctr">
+                    <a:lnL w="6350" cap="flat" cmpd="sng" algn="ctr">
+                      <a:solidFill>
+                        <a:srgbClr val="D5DAE1"/>
+                      </a:solidFill>
+                      <a:prstDash val="solid"/>
+                      <a:round/>
+                      <a:headEnd type="none" w="med" len="med"/>
+                      <a:tailEnd type="none" w="med" len="med"/>
+                    </a:lnL>
+                    <a:lnR w="6350" cap="flat" cmpd="sng" algn="ctr">
+                      <a:solidFill>
+                        <a:srgbClr val="D5DAE1"/>
+                      </a:solidFill>
+                      <a:prstDash val="solid"/>
+                      <a:round/>
+                      <a:headEnd type="none" w="med" len="med"/>
+                      <a:tailEnd type="none" w="med" len="med"/>
+                    </a:lnR>
+                    <a:lnT w="6350" cap="flat" cmpd="sng" algn="ctr">
+                      <a:solidFill>
+                        <a:srgbClr val="D5DAE1"/>
+                      </a:solidFill>
+                      <a:prstDash val="solid"/>
+                      <a:round/>
+                      <a:headEnd type="none" w="med" len="med"/>
+                      <a:tailEnd type="none" w="med" len="med"/>
+                    </a:lnT>
+                    <a:lnB w="6350" cap="flat" cmpd="sng" algn="ctr">
+                      <a:solidFill>
+                        <a:srgbClr val="D5DAE1"/>
+                      </a:solidFill>
+                      <a:prstDash val="solid"/>
+                      <a:round/>
+                      <a:headEnd type="none" w="med" len="med"/>
+                      <a:tailEnd type="none" w="med" len="med"/>
+                    </a:lnB>
+                    <a:solidFill>
+                      <a:srgbClr val="FFFFFF"/>
+                    </a:solidFill>
+                  </a:tcPr>
+                </a:tc>
+              </a:tr>
+              <a:tr h="292608">
+                <a:tc>
+                  <a:txBody>
+                    <a:bodyPr/>
+                    <a:lstStyle/>
+                    <a:p>
+                      <a:pPr algn="l" indent="0" marL="0">
+                        <a:buNone/>
+                      </a:pPr>
+                      <a:r>
+                        <a:rPr lang="en-US" sz="1100" dirty="0">
+                          <a:solidFill>
+                            <a:srgbClr val="1B1F2A"/>
+                          </a:solidFill>
+                        </a:rPr>
+                        <a:t>NPV at 14%</a:t>
+                      </a:r>
+                      <a:endParaRPr lang="en-US" sz="1100" dirty="0"/>
+                    </a:p>
+                  </a:txBody>
+                  <a:tcPr marL="73152" marR="73152" marT="36576" marB="36576" anchor="ctr">
+                    <a:lnL w="6350" cap="flat" cmpd="sng" algn="ctr">
+                      <a:solidFill>
+                        <a:srgbClr val="D5DAE1"/>
+                      </a:solidFill>
+                      <a:prstDash val="solid"/>
+                      <a:round/>
+                      <a:headEnd type="none" w="med" len="med"/>
+                      <a:tailEnd type="none" w="med" len="med"/>
+                    </a:lnL>
+                    <a:lnR w="6350" cap="flat" cmpd="sng" algn="ctr">
+                      <a:solidFill>
+                        <a:srgbClr val="D5DAE1"/>
+                      </a:solidFill>
+                      <a:prstDash val="solid"/>
+                      <a:round/>
+                      <a:headEnd type="none" w="med" len="med"/>
+                      <a:tailEnd type="none" w="med" len="med"/>
+                    </a:lnR>
+                    <a:lnT w="6350" cap="flat" cmpd="sng" algn="ctr">
+                      <a:solidFill>
+                        <a:srgbClr val="D5DAE1"/>
+                      </a:solidFill>
+                      <a:prstDash val="solid"/>
+                      <a:round/>
+                      <a:headEnd type="none" w="med" len="med"/>
+                      <a:tailEnd type="none" w="med" len="med"/>
+                    </a:lnT>
+                    <a:lnB w="6350" cap="flat" cmpd="sng" algn="ctr">
+                      <a:solidFill>
+                        <a:srgbClr val="D5DAE1"/>
+                      </a:solidFill>
+                      <a:prstDash val="solid"/>
+                      <a:round/>
+                      <a:headEnd type="none" w="med" len="med"/>
+                      <a:tailEnd type="none" w="med" len="med"/>
+                    </a:lnB>
+                    <a:solidFill>
+                      <a:srgbClr val="F2F4F7"/>
+                    </a:solidFill>
+                  </a:tcPr>
+                </a:tc>
+                <a:tc>
+                  <a:txBody>
+                    <a:bodyPr/>
+                    <a:lstStyle/>
+                    <a:p>
+                      <a:pPr algn="r" indent="0" marL="0">
+                        <a:buNone/>
+                      </a:pPr>
+                      <a:r>
+                        <a:rPr lang="en-US" sz="1100" dirty="0">
+                          <a:solidFill>
+                            <a:srgbClr val="1B1F2A"/>
+                          </a:solidFill>
+                        </a:rPr>
+                        <a:t>215</a:t>
+                      </a:r>
+                      <a:endParaRPr lang="en-US" sz="1100" dirty="0"/>
+                    </a:p>
+                  </a:txBody>
+                  <a:tcPr marL="73152" marR="73152" marT="36576" marB="36576" anchor="ctr">
+                    <a:lnL w="6350" cap="flat" cmpd="sng" algn="ctr">
+                      <a:solidFill>
+                        <a:srgbClr val="D5DAE1"/>
+                      </a:solidFill>
+                      <a:prstDash val="solid"/>
+                      <a:round/>
+                      <a:headEnd type="none" w="med" len="med"/>
+                      <a:tailEnd type="none" w="med" len="med"/>
+                    </a:lnL>
+                    <a:lnR w="6350" cap="flat" cmpd="sng" algn="ctr">
+                      <a:solidFill>
+                        <a:srgbClr val="D5DAE1"/>
+                      </a:solidFill>
+                      <a:prstDash val="solid"/>
+                      <a:round/>
+                      <a:headEnd type="none" w="med" len="med"/>
+                      <a:tailEnd type="none" w="med" len="med"/>
+                    </a:lnR>
+                    <a:lnT w="6350" cap="flat" cmpd="sng" algn="ctr">
+                      <a:solidFill>
+                        <a:srgbClr val="D5DAE1"/>
+                      </a:solidFill>
+                      <a:prstDash val="solid"/>
+                      <a:round/>
+                      <a:headEnd type="none" w="med" len="med"/>
+                      <a:tailEnd type="none" w="med" len="med"/>
+                    </a:lnT>
+                    <a:lnB w="6350" cap="flat" cmpd="sng" algn="ctr">
+                      <a:solidFill>
+                        <a:srgbClr val="D5DAE1"/>
+                      </a:solidFill>
+                      <a:prstDash val="solid"/>
+                      <a:round/>
+                      <a:headEnd type="none" w="med" len="med"/>
+                      <a:tailEnd type="none" w="med" len="med"/>
+                    </a:lnB>
+                    <a:solidFill>
+                      <a:srgbClr val="F2F4F7"/>
+                    </a:solidFill>
+                  </a:tcPr>
+                </a:tc>
+                <a:tc>
+                  <a:txBody>
+                    <a:bodyPr/>
+                    <a:lstStyle/>
+                    <a:p>
+                      <a:pPr algn="r" indent="0" marL="0">
+                        <a:buNone/>
+                      </a:pPr>
+                      <a:r>
+                        <a:rPr lang="en-US" sz="1100" dirty="0">
+                          <a:solidFill>
+                            <a:srgbClr val="1B1F2A"/>
+                          </a:solidFill>
+                        </a:rPr>
+                        <a:t>308</a:t>
+                      </a:r>
+                      <a:endParaRPr lang="en-US" sz="1100" dirty="0"/>
+                    </a:p>
+                  </a:txBody>
+                  <a:tcPr marL="73152" marR="73152" marT="36576" marB="36576" anchor="ctr">
+                    <a:lnL w="6350" cap="flat" cmpd="sng" algn="ctr">
+                      <a:solidFill>
+                        <a:srgbClr val="D5DAE1"/>
+                      </a:solidFill>
+                      <a:prstDash val="solid"/>
+                      <a:round/>
+                      <a:headEnd type="none" w="med" len="med"/>
+                      <a:tailEnd type="none" w="med" len="med"/>
+                    </a:lnL>
+                    <a:lnR w="6350" cap="flat" cmpd="sng" algn="ctr">
+                      <a:solidFill>
+                        <a:srgbClr val="D5DAE1"/>
+                      </a:solidFill>
+                      <a:prstDash val="solid"/>
+                      <a:round/>
+                      <a:headEnd type="none" w="med" len="med"/>
+                      <a:tailEnd type="none" w="med" len="med"/>
+                    </a:lnR>
+                    <a:lnT w="6350" cap="flat" cmpd="sng" algn="ctr">
+                      <a:solidFill>
+                        <a:srgbClr val="D5DAE1"/>
+                      </a:solidFill>
+                      <a:prstDash val="solid"/>
+                      <a:round/>
+                      <a:headEnd type="none" w="med" len="med"/>
+                      <a:tailEnd type="none" w="med" len="med"/>
+                    </a:lnT>
+                    <a:lnB w="6350" cap="flat" cmpd="sng" algn="ctr">
+                      <a:solidFill>
+                        <a:srgbClr val="D5DAE1"/>
+                      </a:solidFill>
+                      <a:prstDash val="solid"/>
+                      <a:round/>
+                      <a:headEnd type="none" w="med" len="med"/>
+                      <a:tailEnd type="none" w="med" len="med"/>
+                    </a:lnB>
+                    <a:solidFill>
+                      <a:srgbClr val="F2F4F7"/>
+                    </a:solidFill>
+                  </a:tcPr>
+                </a:tc>
+              </a:tr>
+              <a:tr h="292608">
+                <a:tc>
+                  <a:txBody>
+                    <a:bodyPr/>
+                    <a:lstStyle/>
+                    <a:p>
+                      <a:pPr algn="l" indent="0" marL="0">
+                        <a:buNone/>
+                      </a:pPr>
+                      <a:r>
+                        <a:rPr lang="en-US" sz="1100" dirty="0">
+                          <a:solidFill>
+                            <a:srgbClr val="1B1F2A"/>
+                          </a:solidFill>
+                        </a:rPr>
+                        <a:t>Peak shortage (month)</a:t>
+                      </a:r>
+                      <a:endParaRPr lang="en-US" sz="1100" dirty="0"/>
+                    </a:p>
+                  </a:txBody>
+                  <a:tcPr marL="73152" marR="73152" marT="36576" marB="36576" anchor="ctr">
+                    <a:lnL w="6350" cap="flat" cmpd="sng" algn="ctr">
+                      <a:solidFill>
+                        <a:srgbClr val="D5DAE1"/>
+                      </a:solidFill>
+                      <a:prstDash val="solid"/>
+                      <a:round/>
+                      <a:headEnd type="none" w="med" len="med"/>
+                      <a:tailEnd type="none" w="med" len="med"/>
+                    </a:lnL>
+                    <a:lnR w="6350" cap="flat" cmpd="sng" algn="ctr">
+                      <a:solidFill>
+                        <a:srgbClr val="D5DAE1"/>
+                      </a:solidFill>
+                      <a:prstDash val="solid"/>
+                      <a:round/>
+                      <a:headEnd type="none" w="med" len="med"/>
+                      <a:tailEnd type="none" w="med" len="med"/>
+                    </a:lnR>
+                    <a:lnT w="6350" cap="flat" cmpd="sng" algn="ctr">
+                      <a:solidFill>
+                        <a:srgbClr val="D5DAE1"/>
+                      </a:solidFill>
+                      <a:prstDash val="solid"/>
+                      <a:round/>
+                      <a:headEnd type="none" w="med" len="med"/>
+                      <a:tailEnd type="none" w="med" len="med"/>
+                    </a:lnT>
+                    <a:lnB w="6350" cap="flat" cmpd="sng" algn="ctr">
+                      <a:solidFill>
+                        <a:srgbClr val="D5DAE1"/>
+                      </a:solidFill>
+                      <a:prstDash val="solid"/>
+                      <a:round/>
+                      <a:headEnd type="none" w="med" len="med"/>
+                      <a:tailEnd type="none" w="med" len="med"/>
+                    </a:lnB>
+                    <a:solidFill>
+                      <a:srgbClr val="FFFFFF"/>
+                    </a:solidFill>
+                  </a:tcPr>
+                </a:tc>
+                <a:tc>
+                  <a:txBody>
+                    <a:bodyPr/>
+                    <a:lstStyle/>
+                    <a:p>
+                      <a:pPr algn="r" indent="0" marL="0">
+                        <a:buNone/>
+                      </a:pPr>
+                      <a:r>
+                        <a:rPr lang="en-US" sz="1100" dirty="0">
+                          <a:solidFill>
+                            <a:srgbClr val="1B1F2A"/>
+                          </a:solidFill>
+                        </a:rPr>
+                        <a:t>102.5 (6)</a:t>
+                      </a:r>
+                      <a:endParaRPr lang="en-US" sz="1100" dirty="0"/>
+                    </a:p>
+                  </a:txBody>
+                  <a:tcPr marL="73152" marR="73152" marT="36576" marB="36576" anchor="ctr">
+                    <a:lnL w="6350" cap="flat" cmpd="sng" algn="ctr">
+                      <a:solidFill>
+                        <a:srgbClr val="D5DAE1"/>
+                      </a:solidFill>
+                      <a:prstDash val="solid"/>
+                      <a:round/>
+                      <a:headEnd type="none" w="med" len="med"/>
+                      <a:tailEnd type="none" w="med" len="med"/>
+                    </a:lnL>
+                    <a:lnR w="6350" cap="flat" cmpd="sng" algn="ctr">
+                      <a:solidFill>
+                        <a:srgbClr val="D5DAE1"/>
+                      </a:solidFill>
+                      <a:prstDash val="solid"/>
+                      <a:round/>
+                      <a:headEnd type="none" w="med" len="med"/>
+                      <a:tailEnd type="none" w="med" len="med"/>
+                    </a:lnR>
+                    <a:lnT w="6350" cap="flat" cmpd="sng" algn="ctr">
+                      <a:solidFill>
+                        <a:srgbClr val="D5DAE1"/>
+                      </a:solidFill>
+                      <a:prstDash val="solid"/>
+                      <a:round/>
+                      <a:headEnd type="none" w="med" len="med"/>
+                      <a:tailEnd type="none" w="med" len="med"/>
+                    </a:lnT>
+                    <a:lnB w="6350" cap="flat" cmpd="sng" algn="ctr">
+                      <a:solidFill>
+                        <a:srgbClr val="D5DAE1"/>
+                      </a:solidFill>
+                      <a:prstDash val="solid"/>
+                      <a:round/>
+                      <a:headEnd type="none" w="med" len="med"/>
+                      <a:tailEnd type="none" w="med" len="med"/>
+                    </a:lnB>
+                    <a:solidFill>
+                      <a:srgbClr val="FFFFFF"/>
+                    </a:solidFill>
+                  </a:tcPr>
+                </a:tc>
+                <a:tc>
+                  <a:txBody>
+                    <a:bodyPr/>
+                    <a:lstStyle/>
+                    <a:p>
+                      <a:pPr algn="r" indent="0" marL="0">
+                        <a:buNone/>
+                      </a:pPr>
+                      <a:r>
+                        <a:rPr lang="en-US" sz="1100" dirty="0">
+                          <a:solidFill>
+                            <a:srgbClr val="1B1F2A"/>
+                          </a:solidFill>
+                        </a:rPr>
+                        <a:t>102.0 (30)</a:t>
+                      </a:r>
+                      <a:endParaRPr lang="en-US" sz="1100" dirty="0"/>
+                    </a:p>
+                  </a:txBody>
+                  <a:tcPr marL="73152" marR="73152" marT="36576" marB="36576" anchor="ctr">
+                    <a:lnL w="6350" cap="flat" cmpd="sng" algn="ctr">
+                      <a:solidFill>
+                        <a:srgbClr val="D5DAE1"/>
+                      </a:solidFill>
+                      <a:prstDash val="solid"/>
+                      <a:round/>
+                      <a:headEnd type="none" w="med" len="med"/>
+                      <a:tailEnd type="none" w="med" len="med"/>
+                    </a:lnL>
+                    <a:lnR w="6350" cap="flat" cmpd="sng" algn="ctr">
+                      <a:solidFill>
+                        <a:srgbClr val="D5DAE1"/>
+                      </a:solidFill>
+                      <a:prstDash val="solid"/>
+                      <a:round/>
+                      <a:headEnd type="none" w="med" len="med"/>
+                      <a:tailEnd type="none" w="med" len="med"/>
+                    </a:lnR>
+                    <a:lnT w="6350" cap="flat" cmpd="sng" algn="ctr">
+                      <a:solidFill>
+                        <a:srgbClr val="D5DAE1"/>
+                      </a:solidFill>
+                      <a:prstDash val="solid"/>
+                      <a:round/>
+                      <a:headEnd type="none" w="med" len="med"/>
+                      <a:tailEnd type="none" w="med" len="med"/>
+                    </a:lnT>
+                    <a:lnB w="6350" cap="flat" cmpd="sng" algn="ctr">
+                      <a:solidFill>
+                        <a:srgbClr val="D5DAE1"/>
+                      </a:solidFill>
+                      <a:prstDash val="solid"/>
+                      <a:round/>
+                      <a:headEnd type="none" w="med" len="med"/>
+                      <a:tailEnd type="none" w="med" len="med"/>
+                    </a:lnB>
+                    <a:solidFill>
+                      <a:srgbClr val="FFFFFF"/>
+                    </a:solidFill>
+                  </a:tcPr>
+                </a:tc>
+              </a:tr>
+            </a:tbl>
+          </a:graphicData>
+        </a:graphic>
+      </p:graphicFrame>
+      <p:graphicFrame>
+        <p:nvGraphicFramePr>
+          <p:cNvPr id="23" name="Table 1"/>
+          <p:cNvGraphicFramePr>
+            <a:graphicFrameLocks noGrp="1"/>
+          </p:cNvGraphicFramePr>
+          <p:nvPr>
+            <p:extLst>
+              <p:ext uri="{D42A27DB-BD31-4B8C-83A1-F6EECF244321}">
+                <p14:modId xmlns:p14="http://schemas.microsoft.com/office/powerpoint/2010/main" val="1579011935"/>
+              </p:ext>
+            </p:extLst>
+          </p:nvPr>
+        </p:nvGraphicFramePr>
+        <p:xfrm>
+          <a:off x="6675120" y="3246120"/>
+          <a:ext cx="4937760" cy="914400"/>
+        </p:xfrm>
+        <a:graphic>
+          <a:graphicData uri="http://schemas.openxmlformats.org/drawingml/2006/table">
+            <a:tbl>
+              <a:tblPr/>
+              <a:tblGrid>
+                <a:gridCol w="2194560"/>
+                <a:gridCol w="914400"/>
+                <a:gridCol w="914400"/>
+                <a:gridCol w="914400"/>
+              </a:tblGrid>
+              <a:tr h="292608">
+                <a:tc>
+                  <a:txBody>
+                    <a:bodyPr/>
+                    <a:lstStyle/>
+                    <a:p>
+                      <a:pPr algn="l" indent="0" marL="0">
+                        <a:buNone/>
+                      </a:pPr>
+                      <a:r>
+                        <a:rPr lang="en-US" sz="1100" b="1" dirty="0">
+                          <a:solidFill>
+                            <a:srgbClr val="FFFFFF"/>
+                          </a:solidFill>
+                        </a:rPr>
+                        <a:t>Peak shortage (EGP m)</a:t>
+                      </a:r>
+                      <a:endParaRPr lang="en-US" sz="1100" dirty="0"/>
+                    </a:p>
+                  </a:txBody>
+                  <a:tcPr marL="73152" marR="73152" marT="36576" marB="36576" anchor="ctr">
+                    <a:lnL w="6350" cap="flat" cmpd="sng" algn="ctr">
+                      <a:solidFill>
+                        <a:srgbClr val="D5DAE1"/>
+                      </a:solidFill>
+                      <a:prstDash val="solid"/>
+                      <a:round/>
+                      <a:headEnd type="none" w="med" len="med"/>
+                      <a:tailEnd type="none" w="med" len="med"/>
+                    </a:lnL>
+                    <a:lnR w="6350" cap="flat" cmpd="sng" algn="ctr">
+                      <a:solidFill>
+                        <a:srgbClr val="D5DAE1"/>
+                      </a:solidFill>
+                      <a:prstDash val="solid"/>
+                      <a:round/>
+                      <a:headEnd type="none" w="med" len="med"/>
+                      <a:tailEnd type="none" w="med" len="med"/>
+                    </a:lnR>
+                    <a:lnT w="6350" cap="flat" cmpd="sng" algn="ctr">
+                      <a:solidFill>
+                        <a:srgbClr val="D5DAE1"/>
+                      </a:solidFill>
+                      <a:prstDash val="solid"/>
+                      <a:round/>
+                      <a:headEnd type="none" w="med" len="med"/>
+                      <a:tailEnd type="none" w="med" len="med"/>
+                    </a:lnT>
+                    <a:lnB w="6350" cap="flat" cmpd="sng" algn="ctr">
+                      <a:solidFill>
+                        <a:srgbClr val="D5DAE1"/>
+                      </a:solidFill>
+                      <a:prstDash val="solid"/>
+                      <a:round/>
+                      <a:headEnd type="none" w="med" len="med"/>
+                      <a:tailEnd type="none" w="med" len="med"/>
+                    </a:lnB>
+                    <a:solidFill>
+                      <a:srgbClr val="17324D"/>
+                    </a:solidFill>
+                  </a:tcPr>
+                </a:tc>
+                <a:tc>
+                  <a:txBody>
+                    <a:bodyPr/>
+                    <a:lstStyle/>
+                    <a:p>
+                      <a:pPr algn="r" indent="0" marL="0">
+                        <a:buNone/>
+                      </a:pPr>
+                      <a:r>
+                        <a:rPr lang="en-US" sz="1100" b="1" dirty="0">
+                          <a:solidFill>
+                            <a:srgbClr val="FFFFFF"/>
+                          </a:solidFill>
+                        </a:rPr>
+                        <a:t>Green</a:t>
+                      </a:r>
+                      <a:endParaRPr lang="en-US" sz="1100" dirty="0"/>
+                    </a:p>
+                  </a:txBody>
+                  <a:tcPr marL="73152" marR="73152" marT="36576" marB="36576" anchor="ctr">
+                    <a:lnL w="6350" cap="flat" cmpd="sng" algn="ctr">
+                      <a:solidFill>
+                        <a:srgbClr val="D5DAE1"/>
+                      </a:solidFill>
+                      <a:prstDash val="solid"/>
+                      <a:round/>
+                      <a:headEnd type="none" w="med" len="med"/>
+                      <a:tailEnd type="none" w="med" len="med"/>
+                    </a:lnL>
+                    <a:lnR w="6350" cap="flat" cmpd="sng" algn="ctr">
+                      <a:solidFill>
+                        <a:srgbClr val="D5DAE1"/>
+                      </a:solidFill>
+                      <a:prstDash val="solid"/>
+                      <a:round/>
+                      <a:headEnd type="none" w="med" len="med"/>
+                      <a:tailEnd type="none" w="med" len="med"/>
+                    </a:lnR>
+                    <a:lnT w="6350" cap="flat" cmpd="sng" algn="ctr">
+                      <a:solidFill>
+                        <a:srgbClr val="D5DAE1"/>
+                      </a:solidFill>
+                      <a:prstDash val="solid"/>
+                      <a:round/>
+                      <a:headEnd type="none" w="med" len="med"/>
+                      <a:tailEnd type="none" w="med" len="med"/>
+                    </a:lnT>
+                    <a:lnB w="6350" cap="flat" cmpd="sng" algn="ctr">
+                      <a:solidFill>
+                        <a:srgbClr val="D5DAE1"/>
+                      </a:solidFill>
+                      <a:prstDash val="solid"/>
+                      <a:round/>
+                      <a:headEnd type="none" w="med" len="med"/>
+                      <a:tailEnd type="none" w="med" len="med"/>
+                    </a:lnB>
+                    <a:solidFill>
+                      <a:srgbClr val="17324D"/>
+                    </a:solidFill>
+                  </a:tcPr>
+                </a:tc>
+                <a:tc>
+                  <a:txBody>
+                    <a:bodyPr/>
+                    <a:lstStyle/>
+                    <a:p>
+                      <a:pPr algn="r" indent="0" marL="0">
+                        <a:buNone/>
+                      </a:pPr>
+                      <a:r>
+                        <a:rPr lang="en-US" sz="1100" b="1" dirty="0">
+                          <a:solidFill>
+                            <a:srgbClr val="FFFFFF"/>
+                          </a:solidFill>
+                        </a:rPr>
+                        <a:t>L'avenir</a:t>
+                      </a:r>
+                      <a:endParaRPr lang="en-US" sz="1100" dirty="0"/>
+                    </a:p>
+                  </a:txBody>
+                  <a:tcPr marL="73152" marR="73152" marT="36576" marB="36576" anchor="ctr">
+                    <a:lnL w="6350" cap="flat" cmpd="sng" algn="ctr">
+                      <a:solidFill>
+                        <a:srgbClr val="D5DAE1"/>
+                      </a:solidFill>
+                      <a:prstDash val="solid"/>
+                      <a:round/>
+                      <a:headEnd type="none" w="med" len="med"/>
+                      <a:tailEnd type="none" w="med" len="med"/>
+                    </a:lnL>
+                    <a:lnR w="6350" cap="flat" cmpd="sng" algn="ctr">
+                      <a:solidFill>
+                        <a:srgbClr val="D5DAE1"/>
+                      </a:solidFill>
+                      <a:prstDash val="solid"/>
+                      <a:round/>
+                      <a:headEnd type="none" w="med" len="med"/>
+                      <a:tailEnd type="none" w="med" len="med"/>
+                    </a:lnR>
+                    <a:lnT w="6350" cap="flat" cmpd="sng" algn="ctr">
+                      <a:solidFill>
+                        <a:srgbClr val="D5DAE1"/>
+                      </a:solidFill>
+                      <a:prstDash val="solid"/>
+                      <a:round/>
+                      <a:headEnd type="none" w="med" len="med"/>
+                      <a:tailEnd type="none" w="med" len="med"/>
+                    </a:lnT>
+                    <a:lnB w="6350" cap="flat" cmpd="sng" algn="ctr">
+                      <a:solidFill>
+                        <a:srgbClr val="D5DAE1"/>
+                      </a:solidFill>
+                      <a:prstDash val="solid"/>
+                      <a:round/>
+                      <a:headEnd type="none" w="med" len="med"/>
+                      <a:tailEnd type="none" w="med" len="med"/>
+                    </a:lnB>
+                    <a:solidFill>
+                      <a:srgbClr val="17324D"/>
+                    </a:solidFill>
+                  </a:tcPr>
+                </a:tc>
+                <a:tc>
+                  <a:txBody>
+                    <a:bodyPr/>
+                    <a:lstStyle/>
+                    <a:p>
+                      <a:pPr algn="r" indent="0" marL="0">
+                        <a:buNone/>
+                      </a:pPr>
+                      <a:r>
+                        <a:rPr lang="en-US" sz="1100" b="1" dirty="0">
+                          <a:solidFill>
+                            <a:srgbClr val="FFFFFF"/>
+                          </a:solidFill>
+                        </a:rPr>
+                        <a:t>Combined</a:t>
+                      </a:r>
+                      <a:endParaRPr lang="en-US" sz="1100" dirty="0"/>
+                    </a:p>
+                  </a:txBody>
+                  <a:tcPr marL="73152" marR="73152" marT="36576" marB="36576" anchor="ctr">
+                    <a:lnL w="6350" cap="flat" cmpd="sng" algn="ctr">
+                      <a:solidFill>
+                        <a:srgbClr val="D5DAE1"/>
+                      </a:solidFill>
+                      <a:prstDash val="solid"/>
+                      <a:round/>
+                      <a:headEnd type="none" w="med" len="med"/>
+                      <a:tailEnd type="none" w="med" len="med"/>
+                    </a:lnL>
+                    <a:lnR w="6350" cap="flat" cmpd="sng" algn="ctr">
+                      <a:solidFill>
+                        <a:srgbClr val="D5DAE1"/>
+                      </a:solidFill>
+                      <a:prstDash val="solid"/>
+                      <a:round/>
+                      <a:headEnd type="none" w="med" len="med"/>
+                      <a:tailEnd type="none" w="med" len="med"/>
+                    </a:lnR>
+                    <a:lnT w="6350" cap="flat" cmpd="sng" algn="ctr">
+                      <a:solidFill>
+                        <a:srgbClr val="D5DAE1"/>
+                      </a:solidFill>
+                      <a:prstDash val="solid"/>
+                      <a:round/>
+                      <a:headEnd type="none" w="med" len="med"/>
+                      <a:tailEnd type="none" w="med" len="med"/>
+                    </a:lnT>
+                    <a:lnB w="6350" cap="flat" cmpd="sng" algn="ctr">
+                      <a:solidFill>
+                        <a:srgbClr val="D5DAE1"/>
+                      </a:solidFill>
+                      <a:prstDash val="solid"/>
+                      <a:round/>
+                      <a:headEnd type="none" w="med" len="med"/>
+                      <a:tailEnd type="none" w="med" len="med"/>
+                    </a:lnB>
+                    <a:solidFill>
+                      <a:srgbClr val="17324D"/>
+                    </a:solidFill>
+                  </a:tcPr>
+                </a:tc>
+              </a:tr>
+              <a:tr h="292608">
+                <a:tc>
+                  <a:txBody>
+                    <a:bodyPr/>
+                    <a:lstStyle/>
+                    <a:p>
+                      <a:pPr algn="l" indent="0" marL="0">
+                        <a:buNone/>
+                      </a:pPr>
+                      <a:r>
+                        <a:rPr lang="en-US" sz="1100" dirty="0">
+                          <a:solidFill>
+                            <a:srgbClr val="1B1F2A"/>
+                          </a:solidFill>
+                        </a:rPr>
+                        <a:t>Base</a:t>
+                      </a:r>
+                      <a:endParaRPr lang="en-US" sz="1100" dirty="0"/>
+                    </a:p>
+                  </a:txBody>
+                  <a:tcPr marL="73152" marR="73152" marT="36576" marB="36576" anchor="ctr">
+                    <a:lnL w="6350" cap="flat" cmpd="sng" algn="ctr">
+                      <a:solidFill>
+                        <a:srgbClr val="D5DAE1"/>
+                      </a:solidFill>
+                      <a:prstDash val="solid"/>
+                      <a:round/>
+                      <a:headEnd type="none" w="med" len="med"/>
+                      <a:tailEnd type="none" w="med" len="med"/>
+                    </a:lnL>
+                    <a:lnR w="6350" cap="flat" cmpd="sng" algn="ctr">
+                      <a:solidFill>
+                        <a:srgbClr val="D5DAE1"/>
+                      </a:solidFill>
+                      <a:prstDash val="solid"/>
+                      <a:round/>
+                      <a:headEnd type="none" w="med" len="med"/>
+                      <a:tailEnd type="none" w="med" len="med"/>
+                    </a:lnR>
+                    <a:lnT w="6350" cap="flat" cmpd="sng" algn="ctr">
+                      <a:solidFill>
+                        <a:srgbClr val="D5DAE1"/>
+                      </a:solidFill>
+                      <a:prstDash val="solid"/>
+                      <a:round/>
+                      <a:headEnd type="none" w="med" len="med"/>
+                      <a:tailEnd type="none" w="med" len="med"/>
+                    </a:lnT>
+                    <a:lnB w="6350" cap="flat" cmpd="sng" algn="ctr">
+                      <a:solidFill>
+                        <a:srgbClr val="D5DAE1"/>
+                      </a:solidFill>
+                      <a:prstDash val="solid"/>
+                      <a:round/>
+                      <a:headEnd type="none" w="med" len="med"/>
+                      <a:tailEnd type="none" w="med" len="med"/>
+                    </a:lnB>
+                    <a:solidFill>
+                      <a:srgbClr val="FFFFFF"/>
+                    </a:solidFill>
+                  </a:tcPr>
+                </a:tc>
+                <a:tc>
+                  <a:txBody>
+                    <a:bodyPr/>
+                    <a:lstStyle/>
+                    <a:p>
+                      <a:pPr algn="r" indent="0" marL="0">
+                        <a:buNone/>
+                      </a:pPr>
+                      <a:r>
+                        <a:rPr lang="en-US" sz="1100" dirty="0">
+                          <a:solidFill>
+                            <a:srgbClr val="1B1F2A"/>
+                          </a:solidFill>
+                        </a:rPr>
+                        <a:t>103</a:t>
+                      </a:r>
+                      <a:endParaRPr lang="en-US" sz="1100" dirty="0"/>
+                    </a:p>
+                  </a:txBody>
+                  <a:tcPr marL="73152" marR="73152" marT="36576" marB="36576" anchor="ctr">
+                    <a:lnL w="6350" cap="flat" cmpd="sng" algn="ctr">
+                      <a:solidFill>
+                        <a:srgbClr val="D5DAE1"/>
+                      </a:solidFill>
+                      <a:prstDash val="solid"/>
+                      <a:round/>
+                      <a:headEnd type="none" w="med" len="med"/>
+                      <a:tailEnd type="none" w="med" len="med"/>
+                    </a:lnL>
+                    <a:lnR w="6350" cap="flat" cmpd="sng" algn="ctr">
+                      <a:solidFill>
+                        <a:srgbClr val="D5DAE1"/>
+                      </a:solidFill>
+                      <a:prstDash val="solid"/>
+                      <a:round/>
+                      <a:headEnd type="none" w="med" len="med"/>
+                      <a:tailEnd type="none" w="med" len="med"/>
+                    </a:lnR>
+                    <a:lnT w="6350" cap="flat" cmpd="sng" algn="ctr">
+                      <a:solidFill>
+                        <a:srgbClr val="D5DAE1"/>
+                      </a:solidFill>
+                      <a:prstDash val="solid"/>
+                      <a:round/>
+                      <a:headEnd type="none" w="med" len="med"/>
+                      <a:tailEnd type="none" w="med" len="med"/>
+                    </a:lnT>
+                    <a:lnB w="6350" cap="flat" cmpd="sng" algn="ctr">
+                      <a:solidFill>
+                        <a:srgbClr val="D5DAE1"/>
+                      </a:solidFill>
+                      <a:prstDash val="solid"/>
+                      <a:round/>
+                      <a:headEnd type="none" w="med" len="med"/>
+                      <a:tailEnd type="none" w="med" len="med"/>
+                    </a:lnB>
+                    <a:solidFill>
+                      <a:srgbClr val="FFFFFF"/>
+                    </a:solidFill>
+                  </a:tcPr>
+                </a:tc>
+                <a:tc>
+                  <a:txBody>
+                    <a:bodyPr/>
+                    <a:lstStyle/>
+                    <a:p>
+                      <a:pPr algn="r" indent="0" marL="0">
+                        <a:buNone/>
+                      </a:pPr>
+                      <a:r>
+                        <a:rPr lang="en-US" sz="1100" dirty="0">
+                          <a:solidFill>
+                            <a:srgbClr val="1B1F2A"/>
+                          </a:solidFill>
+                        </a:rPr>
+                        <a:t>102</a:t>
+                      </a:r>
+                      <a:endParaRPr lang="en-US" sz="1100" dirty="0"/>
+                    </a:p>
+                  </a:txBody>
+                  <a:tcPr marL="73152" marR="73152" marT="36576" marB="36576" anchor="ctr">
+                    <a:lnL w="6350" cap="flat" cmpd="sng" algn="ctr">
+                      <a:solidFill>
+                        <a:srgbClr val="D5DAE1"/>
+                      </a:solidFill>
+                      <a:prstDash val="solid"/>
+                      <a:round/>
+                      <a:headEnd type="none" w="med" len="med"/>
+                      <a:tailEnd type="none" w="med" len="med"/>
+                    </a:lnL>
+                    <a:lnR w="6350" cap="flat" cmpd="sng" algn="ctr">
+                      <a:solidFill>
+                        <a:srgbClr val="D5DAE1"/>
+                      </a:solidFill>
+                      <a:prstDash val="solid"/>
+                      <a:round/>
+                      <a:headEnd type="none" w="med" len="med"/>
+                      <a:tailEnd type="none" w="med" len="med"/>
+                    </a:lnR>
+                    <a:lnT w="6350" cap="flat" cmpd="sng" algn="ctr">
+                      <a:solidFill>
+                        <a:srgbClr val="D5DAE1"/>
+                      </a:solidFill>
+                      <a:prstDash val="solid"/>
+                      <a:round/>
+                      <a:headEnd type="none" w="med" len="med"/>
+                      <a:tailEnd type="none" w="med" len="med"/>
+                    </a:lnT>
+                    <a:lnB w="6350" cap="flat" cmpd="sng" algn="ctr">
+                      <a:solidFill>
+                        <a:srgbClr val="D5DAE1"/>
+                      </a:solidFill>
+                      <a:prstDash val="solid"/>
+                      <a:round/>
+                      <a:headEnd type="none" w="med" len="med"/>
+                      <a:tailEnd type="none" w="med" len="med"/>
+                    </a:lnB>
+                    <a:solidFill>
+                      <a:srgbClr val="FFFFFF"/>
+                    </a:solidFill>
+                  </a:tcPr>
+                </a:tc>
+                <a:tc>
+                  <a:txBody>
+                    <a:bodyPr/>
+                    <a:lstStyle/>
+                    <a:p>
+                      <a:pPr algn="r" indent="0" marL="0">
+                        <a:buNone/>
+                      </a:pPr>
+                      <a:r>
+                        <a:rPr lang="en-US" sz="1100" dirty="0">
+                          <a:solidFill>
+                            <a:srgbClr val="1B1F2A"/>
+                          </a:solidFill>
+                        </a:rPr>
+                        <a:t>168</a:t>
+                      </a:r>
+                      <a:endParaRPr lang="en-US" sz="1100" dirty="0"/>
+                    </a:p>
+                  </a:txBody>
+                  <a:tcPr marL="73152" marR="73152" marT="36576" marB="36576" anchor="ctr">
+                    <a:lnL w="6350" cap="flat" cmpd="sng" algn="ctr">
+                      <a:solidFill>
+                        <a:srgbClr val="D5DAE1"/>
+                      </a:solidFill>
+                      <a:prstDash val="solid"/>
+                      <a:round/>
+                      <a:headEnd type="none" w="med" len="med"/>
+                      <a:tailEnd type="none" w="med" len="med"/>
+                    </a:lnL>
+                    <a:lnR w="6350" cap="flat" cmpd="sng" algn="ctr">
+                      <a:solidFill>
+                        <a:srgbClr val="D5DAE1"/>
+                      </a:solidFill>
+                      <a:prstDash val="solid"/>
+                      <a:round/>
+                      <a:headEnd type="none" w="med" len="med"/>
+                      <a:tailEnd type="none" w="med" len="med"/>
+                    </a:lnR>
+                    <a:lnT w="6350" cap="flat" cmpd="sng" algn="ctr">
+                      <a:solidFill>
+                        <a:srgbClr val="D5DAE1"/>
+                      </a:solidFill>
+                      <a:prstDash val="solid"/>
+                      <a:round/>
+                      <a:headEnd type="none" w="med" len="med"/>
+                      <a:tailEnd type="none" w="med" len="med"/>
+                    </a:lnT>
+                    <a:lnB w="6350" cap="flat" cmpd="sng" algn="ctr">
+                      <a:solidFill>
+                        <a:srgbClr val="D5DAE1"/>
+                      </a:solidFill>
+                      <a:prstDash val="solid"/>
+                      <a:round/>
+                      <a:headEnd type="none" w="med" len="med"/>
+                      <a:tailEnd type="none" w="med" len="med"/>
+                    </a:lnB>
+                    <a:solidFill>
+                      <a:srgbClr val="FFFFFF"/>
+                    </a:solidFill>
+                  </a:tcPr>
+                </a:tc>
+              </a:tr>
+              <a:tr h="292608">
+                <a:tc>
+                  <a:txBody>
+                    <a:bodyPr/>
+                    <a:lstStyle/>
+                    <a:p>
+                      <a:pPr algn="l" indent="0" marL="0">
+                        <a:buNone/>
+                      </a:pPr>
+                      <a:r>
+                        <a:rPr lang="en-US" sz="1100" dirty="0">
+                          <a:solidFill>
+                            <a:srgbClr val="1B1F2A"/>
+                          </a:solidFill>
+                        </a:rPr>
+                        <a:t>Delivery payments at handover</a:t>
+                      </a:r>
+                      <a:endParaRPr lang="en-US" sz="1100" dirty="0"/>
+                    </a:p>
+                  </a:txBody>
+                  <a:tcPr marL="73152" marR="73152" marT="36576" marB="36576" anchor="ctr">
+                    <a:lnL w="6350" cap="flat" cmpd="sng" algn="ctr">
+                      <a:solidFill>
+                        <a:srgbClr val="D5DAE1"/>
+                      </a:solidFill>
+                      <a:prstDash val="solid"/>
+                      <a:round/>
+                      <a:headEnd type="none" w="med" len="med"/>
+                      <a:tailEnd type="none" w="med" len="med"/>
+                    </a:lnL>
+                    <a:lnR w="6350" cap="flat" cmpd="sng" algn="ctr">
+                      <a:solidFill>
+                        <a:srgbClr val="D5DAE1"/>
+                      </a:solidFill>
+                      <a:prstDash val="solid"/>
+                      <a:round/>
+                      <a:headEnd type="none" w="med" len="med"/>
+                      <a:tailEnd type="none" w="med" len="med"/>
+                    </a:lnR>
+                    <a:lnT w="6350" cap="flat" cmpd="sng" algn="ctr">
+                      <a:solidFill>
+                        <a:srgbClr val="D5DAE1"/>
+                      </a:solidFill>
+                      <a:prstDash val="solid"/>
+                      <a:round/>
+                      <a:headEnd type="none" w="med" len="med"/>
+                      <a:tailEnd type="none" w="med" len="med"/>
+                    </a:lnT>
+                    <a:lnB w="6350" cap="flat" cmpd="sng" algn="ctr">
+                      <a:solidFill>
+                        <a:srgbClr val="D5DAE1"/>
+                      </a:solidFill>
+                      <a:prstDash val="solid"/>
+                      <a:round/>
+                      <a:headEnd type="none" w="med" len="med"/>
+                      <a:tailEnd type="none" w="med" len="med"/>
+                    </a:lnB>
+                    <a:solidFill>
+                      <a:srgbClr val="F2F4F7"/>
+                    </a:solidFill>
+                  </a:tcPr>
+                </a:tc>
+                <a:tc>
+                  <a:txBody>
+                    <a:bodyPr/>
+                    <a:lstStyle/>
+                    <a:p>
+                      <a:pPr algn="r" indent="0" marL="0">
+                        <a:buNone/>
+                      </a:pPr>
+                      <a:r>
+                        <a:rPr lang="en-US" sz="1100" dirty="0">
+                          <a:solidFill>
+                            <a:srgbClr val="1B1F2A"/>
+                          </a:solidFill>
+                        </a:rPr>
+                        <a:t>269</a:t>
+                      </a:r>
+                      <a:endParaRPr lang="en-US" sz="1100" dirty="0"/>
+                    </a:p>
+                  </a:txBody>
+                  <a:tcPr marL="73152" marR="73152" marT="36576" marB="36576" anchor="ctr">
+                    <a:lnL w="6350" cap="flat" cmpd="sng" algn="ctr">
+                      <a:solidFill>
+                        <a:srgbClr val="D5DAE1"/>
+                      </a:solidFill>
+                      <a:prstDash val="solid"/>
+                      <a:round/>
+                      <a:headEnd type="none" w="med" len="med"/>
+                      <a:tailEnd type="none" w="med" len="med"/>
+                    </a:lnL>
+                    <a:lnR w="6350" cap="flat" cmpd="sng" algn="ctr">
+                      <a:solidFill>
+                        <a:srgbClr val="D5DAE1"/>
+                      </a:solidFill>
+                      <a:prstDash val="solid"/>
+                      <a:round/>
+                      <a:headEnd type="none" w="med" len="med"/>
+                      <a:tailEnd type="none" w="med" len="med"/>
+                    </a:lnR>
+                    <a:lnT w="6350" cap="flat" cmpd="sng" algn="ctr">
+                      <a:solidFill>
+                        <a:srgbClr val="D5DAE1"/>
+                      </a:solidFill>
+                      <a:prstDash val="solid"/>
+                      <a:round/>
+                      <a:headEnd type="none" w="med" len="med"/>
+                      <a:tailEnd type="none" w="med" len="med"/>
+                    </a:lnT>
+                    <a:lnB w="6350" cap="flat" cmpd="sng" algn="ctr">
+                      <a:solidFill>
+                        <a:srgbClr val="D5DAE1"/>
+                      </a:solidFill>
+                      <a:prstDash val="solid"/>
+                      <a:round/>
+                      <a:headEnd type="none" w="med" len="med"/>
+                      <a:tailEnd type="none" w="med" len="med"/>
+                    </a:lnB>
+                    <a:solidFill>
+                      <a:srgbClr val="F2F4F7"/>
+                    </a:solidFill>
+                  </a:tcPr>
+                </a:tc>
+                <a:tc>
+                  <a:txBody>
+                    <a:bodyPr/>
+                    <a:lstStyle/>
+                    <a:p>
+                      <a:pPr algn="r" indent="0" marL="0">
+                        <a:buNone/>
+                      </a:pPr>
+                      <a:r>
+                        <a:rPr lang="en-US" sz="1100" dirty="0">
+                          <a:solidFill>
+                            <a:srgbClr val="1B1F2A"/>
+                          </a:solidFill>
+                        </a:rPr>
+                        <a:t>244</a:t>
+                      </a:r>
+                      <a:endParaRPr lang="en-US" sz="1100" dirty="0"/>
+                    </a:p>
+                  </a:txBody>
+                  <a:tcPr marL="73152" marR="73152" marT="36576" marB="36576" anchor="ctr">
+                    <a:lnL w="6350" cap="flat" cmpd="sng" algn="ctr">
+                      <a:solidFill>
+                        <a:srgbClr val="D5DAE1"/>
+                      </a:solidFill>
+                      <a:prstDash val="solid"/>
+                      <a:round/>
+                      <a:headEnd type="none" w="med" len="med"/>
+                      <a:tailEnd type="none" w="med" len="med"/>
+                    </a:lnL>
+                    <a:lnR w="6350" cap="flat" cmpd="sng" algn="ctr">
+                      <a:solidFill>
+                        <a:srgbClr val="D5DAE1"/>
+                      </a:solidFill>
+                      <a:prstDash val="solid"/>
+                      <a:round/>
+                      <a:headEnd type="none" w="med" len="med"/>
+                      <a:tailEnd type="none" w="med" len="med"/>
+                    </a:lnR>
+                    <a:lnT w="6350" cap="flat" cmpd="sng" algn="ctr">
+                      <a:solidFill>
+                        <a:srgbClr val="D5DAE1"/>
+                      </a:solidFill>
+                      <a:prstDash val="solid"/>
+                      <a:round/>
+                      <a:headEnd type="none" w="med" len="med"/>
+                      <a:tailEnd type="none" w="med" len="med"/>
+                    </a:lnT>
+                    <a:lnB w="6350" cap="flat" cmpd="sng" algn="ctr">
+                      <a:solidFill>
+                        <a:srgbClr val="D5DAE1"/>
+                      </a:solidFill>
+                      <a:prstDash val="solid"/>
+                      <a:round/>
+                      <a:headEnd type="none" w="med" len="med"/>
+                      <a:tailEnd type="none" w="med" len="med"/>
+                    </a:lnB>
+                    <a:solidFill>
+                      <a:srgbClr val="F2F4F7"/>
+                    </a:solidFill>
+                  </a:tcPr>
+                </a:tc>
+                <a:tc>
+                  <a:txBody>
+                    <a:bodyPr/>
+                    <a:lstStyle/>
+                    <a:p>
+                      <a:pPr algn="r" indent="0" marL="0">
+                        <a:buNone/>
+                      </a:pPr>
+                      <a:r>
+                        <a:rPr lang="en-US" sz="1100" dirty="0">
+                          <a:solidFill>
+                            <a:srgbClr val="1B1F2A"/>
+                          </a:solidFill>
+                        </a:rPr>
+                        <a:t>318</a:t>
+                      </a:r>
+                      <a:endParaRPr lang="en-US" sz="1100" dirty="0"/>
+                    </a:p>
+                  </a:txBody>
+                  <a:tcPr marL="73152" marR="73152" marT="36576" marB="36576" anchor="ctr">
+                    <a:lnL w="6350" cap="flat" cmpd="sng" algn="ctr">
+                      <a:solidFill>
+                        <a:srgbClr val="D5DAE1"/>
+                      </a:solidFill>
+                      <a:prstDash val="solid"/>
+                      <a:round/>
+                      <a:headEnd type="none" w="med" len="med"/>
+                      <a:tailEnd type="none" w="med" len="med"/>
+                    </a:lnL>
+                    <a:lnR w="6350" cap="flat" cmpd="sng" algn="ctr">
+                      <a:solidFill>
+                        <a:srgbClr val="D5DAE1"/>
+                      </a:solidFill>
+                      <a:prstDash val="solid"/>
+                      <a:round/>
+                      <a:headEnd type="none" w="med" len="med"/>
+                      <a:tailEnd type="none" w="med" len="med"/>
+                    </a:lnR>
+                    <a:lnT w="6350" cap="flat" cmpd="sng" algn="ctr">
+                      <a:solidFill>
+                        <a:srgbClr val="D5DAE1"/>
+                      </a:solidFill>
+                      <a:prstDash val="solid"/>
+                      <a:round/>
+                      <a:headEnd type="none" w="med" len="med"/>
+                      <a:tailEnd type="none" w="med" len="med"/>
+                    </a:lnT>
+                    <a:lnB w="6350" cap="flat" cmpd="sng" algn="ctr">
+                      <a:solidFill>
+                        <a:srgbClr val="D5DAE1"/>
+                      </a:solidFill>
+                      <a:prstDash val="solid"/>
+                      <a:round/>
+                      <a:headEnd type="none" w="med" len="med"/>
+                      <a:tailEnd type="none" w="med" len="med"/>
+                    </a:lnB>
+                    <a:solidFill>
+                      <a:srgbClr val="F2F4F7"/>
+                    </a:solidFill>
+                  </a:tcPr>
+                </a:tc>
+              </a:tr>
+              <a:tr h="292608">
+                <a:tc>
+                  <a:txBody>
+                    <a:bodyPr/>
+                    <a:lstStyle/>
+                    <a:p>
+                      <a:pPr algn="l" indent="0" marL="0">
+                        <a:buNone/>
+                      </a:pPr>
+                      <a:r>
+                        <a:rPr lang="en-US" sz="1100" dirty="0">
+                          <a:solidFill>
+                            <a:srgbClr val="1B1F2A"/>
+                          </a:solidFill>
+                        </a:rPr>
+                        <a:t>Collections slip 2 quarters</a:t>
+                      </a:r>
+                      <a:endParaRPr lang="en-US" sz="1100" dirty="0"/>
+                    </a:p>
+                  </a:txBody>
+                  <a:tcPr marL="73152" marR="73152" marT="36576" marB="36576" anchor="ctr">
+                    <a:lnL w="6350" cap="flat" cmpd="sng" algn="ctr">
+                      <a:solidFill>
+                        <a:srgbClr val="D5DAE1"/>
+                      </a:solidFill>
+                      <a:prstDash val="solid"/>
+                      <a:round/>
+                      <a:headEnd type="none" w="med" len="med"/>
+                      <a:tailEnd type="none" w="med" len="med"/>
+                    </a:lnL>
+                    <a:lnR w="6350" cap="flat" cmpd="sng" algn="ctr">
+                      <a:solidFill>
+                        <a:srgbClr val="D5DAE1"/>
+                      </a:solidFill>
+                      <a:prstDash val="solid"/>
+                      <a:round/>
+                      <a:headEnd type="none" w="med" len="med"/>
+                      <a:tailEnd type="none" w="med" len="med"/>
+                    </a:lnR>
+                    <a:lnT w="6350" cap="flat" cmpd="sng" algn="ctr">
+                      <a:solidFill>
+                        <a:srgbClr val="D5DAE1"/>
+                      </a:solidFill>
+                      <a:prstDash val="solid"/>
+                      <a:round/>
+                      <a:headEnd type="none" w="med" len="med"/>
+                      <a:tailEnd type="none" w="med" len="med"/>
+                    </a:lnT>
+                    <a:lnB w="6350" cap="flat" cmpd="sng" algn="ctr">
+                      <a:solidFill>
+                        <a:srgbClr val="D5DAE1"/>
+                      </a:solidFill>
+                      <a:prstDash val="solid"/>
+                      <a:round/>
+                      <a:headEnd type="none" w="med" len="med"/>
+                      <a:tailEnd type="none" w="med" len="med"/>
+                    </a:lnB>
+                    <a:solidFill>
+                      <a:srgbClr val="FFFFFF"/>
+                    </a:solidFill>
+                  </a:tcPr>
+                </a:tc>
+                <a:tc>
+                  <a:txBody>
+                    <a:bodyPr/>
+                    <a:lstStyle/>
+                    <a:p>
+                      <a:pPr algn="r" indent="0" marL="0">
+                        <a:buNone/>
+                      </a:pPr>
+                      <a:r>
+                        <a:rPr lang="en-US" sz="1100" dirty="0">
+                          <a:solidFill>
+                            <a:srgbClr val="1B1F2A"/>
+                          </a:solidFill>
+                        </a:rPr>
+                        <a:t>236</a:t>
+                      </a:r>
+                      <a:endParaRPr lang="en-US" sz="1100" dirty="0"/>
+                    </a:p>
+                  </a:txBody>
+                  <a:tcPr marL="73152" marR="73152" marT="36576" marB="36576" anchor="ctr">
+                    <a:lnL w="6350" cap="flat" cmpd="sng" algn="ctr">
+                      <a:solidFill>
+                        <a:srgbClr val="D5DAE1"/>
+                      </a:solidFill>
+                      <a:prstDash val="solid"/>
+                      <a:round/>
+                      <a:headEnd type="none" w="med" len="med"/>
+                      <a:tailEnd type="none" w="med" len="med"/>
+                    </a:lnL>
+                    <a:lnR w="6350" cap="flat" cmpd="sng" algn="ctr">
+                      <a:solidFill>
+                        <a:srgbClr val="D5DAE1"/>
+                      </a:solidFill>
+                      <a:prstDash val="solid"/>
+                      <a:round/>
+                      <a:headEnd type="none" w="med" len="med"/>
+                      <a:tailEnd type="none" w="med" len="med"/>
+                    </a:lnR>
+                    <a:lnT w="6350" cap="flat" cmpd="sng" algn="ctr">
+                      <a:solidFill>
+                        <a:srgbClr val="D5DAE1"/>
+                      </a:solidFill>
+                      <a:prstDash val="solid"/>
+                      <a:round/>
+                      <a:headEnd type="none" w="med" len="med"/>
+                      <a:tailEnd type="none" w="med" len="med"/>
+                    </a:lnT>
+                    <a:lnB w="6350" cap="flat" cmpd="sng" algn="ctr">
+                      <a:solidFill>
+                        <a:srgbClr val="D5DAE1"/>
+                      </a:solidFill>
+                      <a:prstDash val="solid"/>
+                      <a:round/>
+                      <a:headEnd type="none" w="med" len="med"/>
+                      <a:tailEnd type="none" w="med" len="med"/>
+                    </a:lnB>
+                    <a:solidFill>
+                      <a:srgbClr val="FFFFFF"/>
+                    </a:solidFill>
+                  </a:tcPr>
+                </a:tc>
+                <a:tc>
+                  <a:txBody>
+                    <a:bodyPr/>
+                    <a:lstStyle/>
+                    <a:p>
+                      <a:pPr algn="r" indent="0" marL="0">
+                        <a:buNone/>
+                      </a:pPr>
+                      <a:r>
+                        <a:rPr lang="en-US" sz="1100" dirty="0">
+                          <a:solidFill>
+                            <a:srgbClr val="1B1F2A"/>
+                          </a:solidFill>
+                        </a:rPr>
+                        <a:t>381</a:t>
+                      </a:r>
+                      <a:endParaRPr lang="en-US" sz="1100" dirty="0"/>
+                    </a:p>
+                  </a:txBody>
+                  <a:tcPr marL="73152" marR="73152" marT="36576" marB="36576" anchor="ctr">
+                    <a:lnL w="6350" cap="flat" cmpd="sng" algn="ctr">
+                      <a:solidFill>
+                        <a:srgbClr val="D5DAE1"/>
+                      </a:solidFill>
+                      <a:prstDash val="solid"/>
+                      <a:round/>
+                      <a:headEnd type="none" w="med" len="med"/>
+                      <a:tailEnd type="none" w="med" len="med"/>
+                    </a:lnL>
+                    <a:lnR w="6350" cap="flat" cmpd="sng" algn="ctr">
+                      <a:solidFill>
+                        <a:srgbClr val="D5DAE1"/>
+                      </a:solidFill>
+                      <a:prstDash val="solid"/>
+                      <a:round/>
+                      <a:headEnd type="none" w="med" len="med"/>
+                      <a:tailEnd type="none" w="med" len="med"/>
+                    </a:lnR>
+                    <a:lnT w="6350" cap="flat" cmpd="sng" algn="ctr">
+                      <a:solidFill>
+                        <a:srgbClr val="D5DAE1"/>
+                      </a:solidFill>
+                      <a:prstDash val="solid"/>
+                      <a:round/>
+                      <a:headEnd type="none" w="med" len="med"/>
+                      <a:tailEnd type="none" w="med" len="med"/>
+                    </a:lnT>
+                    <a:lnB w="6350" cap="flat" cmpd="sng" algn="ctr">
+                      <a:solidFill>
+                        <a:srgbClr val="D5DAE1"/>
+                      </a:solidFill>
+                      <a:prstDash val="solid"/>
+                      <a:round/>
+                      <a:headEnd type="none" w="med" len="med"/>
+                      <a:tailEnd type="none" w="med" len="med"/>
+                    </a:lnB>
+                    <a:solidFill>
+                      <a:srgbClr val="FFFFFF"/>
+                    </a:solidFill>
+                  </a:tcPr>
+                </a:tc>
+                <a:tc>
+                  <a:txBody>
+                    <a:bodyPr/>
+                    <a:lstStyle/>
+                    <a:p>
+                      <a:pPr algn="r" indent="0" marL="0">
+                        <a:buNone/>
+                      </a:pPr>
+                      <a:r>
+                        <a:rPr lang="en-US" sz="1100" dirty="0">
+                          <a:solidFill>
+                            <a:srgbClr val="1B1F2A"/>
+                          </a:solidFill>
+                        </a:rPr>
+                        <a:t>478</a:t>
+                      </a:r>
+                      <a:endParaRPr lang="en-US" sz="1100" dirty="0"/>
+                    </a:p>
+                  </a:txBody>
+                  <a:tcPr marL="73152" marR="73152" marT="36576" marB="36576" anchor="ctr">
+                    <a:lnL w="6350" cap="flat" cmpd="sng" algn="ctr">
+                      <a:solidFill>
+                        <a:srgbClr val="D5DAE1"/>
+                      </a:solidFill>
+                      <a:prstDash val="solid"/>
+                      <a:round/>
+                      <a:headEnd type="none" w="med" len="med"/>
+                      <a:tailEnd type="none" w="med" len="med"/>
+                    </a:lnL>
+                    <a:lnR w="6350" cap="flat" cmpd="sng" algn="ctr">
+                      <a:solidFill>
+                        <a:srgbClr val="D5DAE1"/>
+                      </a:solidFill>
+                      <a:prstDash val="solid"/>
+                      <a:round/>
+                      <a:headEnd type="none" w="med" len="med"/>
+                      <a:tailEnd type="none" w="med" len="med"/>
+                    </a:lnR>
+                    <a:lnT w="6350" cap="flat" cmpd="sng" algn="ctr">
+                      <a:solidFill>
+                        <a:srgbClr val="D5DAE1"/>
+                      </a:solidFill>
+                      <a:prstDash val="solid"/>
+                      <a:round/>
+                      <a:headEnd type="none" w="med" len="med"/>
+                      <a:tailEnd type="none" w="med" len="med"/>
+                    </a:lnT>
+                    <a:lnB w="6350" cap="flat" cmpd="sng" algn="ctr">
+                      <a:solidFill>
+                        <a:srgbClr val="D5DAE1"/>
+                      </a:solidFill>
+                      <a:prstDash val="solid"/>
+                      <a:round/>
+                      <a:headEnd type="none" w="med" len="med"/>
+                      <a:tailEnd type="none" w="med" len="med"/>
+                    </a:lnB>
+                    <a:solidFill>
+                      <a:srgbClr val="FFFFFF"/>
+                    </a:solidFill>
+                  </a:tcPr>
+                </a:tc>
+              </a:tr>
+              <a:tr h="292608">
+                <a:tc>
+                  <a:txBody>
+                    <a:bodyPr/>
+                    <a:lstStyle/>
+                    <a:p>
+                      <a:pPr algn="l" indent="0" marL="0">
+                        <a:buNone/>
+                      </a:pPr>
+                      <a:r>
+                        <a:rPr lang="en-US" sz="1100" dirty="0">
+                          <a:solidFill>
+                            <a:srgbClr val="1B1F2A"/>
+                          </a:solidFill>
+                        </a:rPr>
+                        <a:t>Sales +12 months, prices -10%</a:t>
+                      </a:r>
+                      <a:endParaRPr lang="en-US" sz="1100" dirty="0"/>
+                    </a:p>
+                  </a:txBody>
+                  <a:tcPr marL="73152" marR="73152" marT="36576" marB="36576" anchor="ctr">
+                    <a:lnL w="6350" cap="flat" cmpd="sng" algn="ctr">
+                      <a:solidFill>
+                        <a:srgbClr val="D5DAE1"/>
+                      </a:solidFill>
+                      <a:prstDash val="solid"/>
+                      <a:round/>
+                      <a:headEnd type="none" w="med" len="med"/>
+                      <a:tailEnd type="none" w="med" len="med"/>
+                    </a:lnL>
+                    <a:lnR w="6350" cap="flat" cmpd="sng" algn="ctr">
+                      <a:solidFill>
+                        <a:srgbClr val="D5DAE1"/>
+                      </a:solidFill>
+                      <a:prstDash val="solid"/>
+                      <a:round/>
+                      <a:headEnd type="none" w="med" len="med"/>
+                      <a:tailEnd type="none" w="med" len="med"/>
+                    </a:lnR>
+                    <a:lnT w="6350" cap="flat" cmpd="sng" algn="ctr">
+                      <a:solidFill>
+                        <a:srgbClr val="D5DAE1"/>
+                      </a:solidFill>
+                      <a:prstDash val="solid"/>
+                      <a:round/>
+                      <a:headEnd type="none" w="med" len="med"/>
+                      <a:tailEnd type="none" w="med" len="med"/>
+                    </a:lnT>
+                    <a:lnB w="6350" cap="flat" cmpd="sng" algn="ctr">
+                      <a:solidFill>
+                        <a:srgbClr val="D5DAE1"/>
+                      </a:solidFill>
+                      <a:prstDash val="solid"/>
+                      <a:round/>
+                      <a:headEnd type="none" w="med" len="med"/>
+                      <a:tailEnd type="none" w="med" len="med"/>
+                    </a:lnB>
+                    <a:solidFill>
+                      <a:srgbClr val="F2F4F7"/>
+                    </a:solidFill>
+                  </a:tcPr>
+                </a:tc>
+                <a:tc>
+                  <a:txBody>
+                    <a:bodyPr/>
+                    <a:lstStyle/>
+                    <a:p>
+                      <a:pPr algn="r" indent="0" marL="0">
+                        <a:buNone/>
+                      </a:pPr>
+                      <a:r>
+                        <a:rPr lang="en-US" sz="1100" dirty="0">
+                          <a:solidFill>
+                            <a:srgbClr val="1B1F2A"/>
+                          </a:solidFill>
+                        </a:rPr>
+                        <a:t>441</a:t>
+                      </a:r>
+                      <a:endParaRPr lang="en-US" sz="1100" dirty="0"/>
+                    </a:p>
+                  </a:txBody>
+                  <a:tcPr marL="73152" marR="73152" marT="36576" marB="36576" anchor="ctr">
+                    <a:lnL w="6350" cap="flat" cmpd="sng" algn="ctr">
+                      <a:solidFill>
+                        <a:srgbClr val="D5DAE1"/>
+                      </a:solidFill>
+                      <a:prstDash val="solid"/>
+                      <a:round/>
+                      <a:headEnd type="none" w="med" len="med"/>
+                      <a:tailEnd type="none" w="med" len="med"/>
+                    </a:lnL>
+                    <a:lnR w="6350" cap="flat" cmpd="sng" algn="ctr">
+                      <a:solidFill>
+                        <a:srgbClr val="D5DAE1"/>
+                      </a:solidFill>
+                      <a:prstDash val="solid"/>
+                      <a:round/>
+                      <a:headEnd type="none" w="med" len="med"/>
+                      <a:tailEnd type="none" w="med" len="med"/>
+                    </a:lnR>
+                    <a:lnT w="6350" cap="flat" cmpd="sng" algn="ctr">
+                      <a:solidFill>
+                        <a:srgbClr val="D5DAE1"/>
+                      </a:solidFill>
+                      <a:prstDash val="solid"/>
+                      <a:round/>
+                      <a:headEnd type="none" w="med" len="med"/>
+                      <a:tailEnd type="none" w="med" len="med"/>
+                    </a:lnT>
+                    <a:lnB w="6350" cap="flat" cmpd="sng" algn="ctr">
+                      <a:solidFill>
+                        <a:srgbClr val="D5DAE1"/>
+                      </a:solidFill>
+                      <a:prstDash val="solid"/>
+                      <a:round/>
+                      <a:headEnd type="none" w="med" len="med"/>
+                      <a:tailEnd type="none" w="med" len="med"/>
+                    </a:lnB>
+                    <a:solidFill>
+                      <a:srgbClr val="F2F4F7"/>
+                    </a:solidFill>
+                  </a:tcPr>
+                </a:tc>
+                <a:tc>
+                  <a:txBody>
+                    <a:bodyPr/>
+                    <a:lstStyle/>
+                    <a:p>
+                      <a:pPr algn="r" indent="0" marL="0">
+                        <a:buNone/>
+                      </a:pPr>
+                      <a:r>
+                        <a:rPr lang="en-US" sz="1100" dirty="0">
+                          <a:solidFill>
+                            <a:srgbClr val="1B1F2A"/>
+                          </a:solidFill>
+                        </a:rPr>
+                        <a:t>849</a:t>
+                      </a:r>
+                      <a:endParaRPr lang="en-US" sz="1100" dirty="0"/>
+                    </a:p>
+                  </a:txBody>
+                  <a:tcPr marL="73152" marR="73152" marT="36576" marB="36576" anchor="ctr">
+                    <a:lnL w="6350" cap="flat" cmpd="sng" algn="ctr">
+                      <a:solidFill>
+                        <a:srgbClr val="D5DAE1"/>
+                      </a:solidFill>
+                      <a:prstDash val="solid"/>
+                      <a:round/>
+                      <a:headEnd type="none" w="med" len="med"/>
+                      <a:tailEnd type="none" w="med" len="med"/>
+                    </a:lnL>
+                    <a:lnR w="6350" cap="flat" cmpd="sng" algn="ctr">
+                      <a:solidFill>
+                        <a:srgbClr val="D5DAE1"/>
+                      </a:solidFill>
+                      <a:prstDash val="solid"/>
+                      <a:round/>
+                      <a:headEnd type="none" w="med" len="med"/>
+                      <a:tailEnd type="none" w="med" len="med"/>
+                    </a:lnR>
+                    <a:lnT w="6350" cap="flat" cmpd="sng" algn="ctr">
+                      <a:solidFill>
+                        <a:srgbClr val="D5DAE1"/>
+                      </a:solidFill>
+                      <a:prstDash val="solid"/>
+                      <a:round/>
+                      <a:headEnd type="none" w="med" len="med"/>
+                      <a:tailEnd type="none" w="med" len="med"/>
+                    </a:lnT>
+                    <a:lnB w="6350" cap="flat" cmpd="sng" algn="ctr">
+                      <a:solidFill>
+                        <a:srgbClr val="D5DAE1"/>
+                      </a:solidFill>
+                      <a:prstDash val="solid"/>
+                      <a:round/>
+                      <a:headEnd type="none" w="med" len="med"/>
+                      <a:tailEnd type="none" w="med" len="med"/>
+                    </a:lnB>
+                    <a:solidFill>
+                      <a:srgbClr val="F2F4F7"/>
+                    </a:solidFill>
+                  </a:tcPr>
+                </a:tc>
+                <a:tc>
+                  <a:txBody>
+                    <a:bodyPr/>
+                    <a:lstStyle/>
+                    <a:p>
+                      <a:pPr algn="r" indent="0" marL="0">
+                        <a:buNone/>
+                      </a:pPr>
+                      <a:r>
+                        <a:rPr lang="en-US" sz="1100" dirty="0">
+                          <a:solidFill>
+                            <a:srgbClr val="1B1F2A"/>
+                          </a:solidFill>
+                        </a:rPr>
+                        <a:t>1,089</a:t>
+                      </a:r>
+                      <a:endParaRPr lang="en-US" sz="1100" dirty="0"/>
+                    </a:p>
+                  </a:txBody>
+                  <a:tcPr marL="73152" marR="73152" marT="36576" marB="36576" anchor="ctr">
+                    <a:lnL w="6350" cap="flat" cmpd="sng" algn="ctr">
+                      <a:solidFill>
+                        <a:srgbClr val="D5DAE1"/>
+                      </a:solidFill>
+                      <a:prstDash val="solid"/>
+                      <a:round/>
+                      <a:headEnd type="none" w="med" len="med"/>
+                      <a:tailEnd type="none" w="med" len="med"/>
+                    </a:lnL>
+                    <a:lnR w="6350" cap="flat" cmpd="sng" algn="ctr">
+                      <a:solidFill>
+                        <a:srgbClr val="D5DAE1"/>
+                      </a:solidFill>
+                      <a:prstDash val="solid"/>
+                      <a:round/>
+                      <a:headEnd type="none" w="med" len="med"/>
+                      <a:tailEnd type="none" w="med" len="med"/>
+                    </a:lnR>
+                    <a:lnT w="6350" cap="flat" cmpd="sng" algn="ctr">
+                      <a:solidFill>
+                        <a:srgbClr val="D5DAE1"/>
+                      </a:solidFill>
+                      <a:prstDash val="solid"/>
+                      <a:round/>
+                      <a:headEnd type="none" w="med" len="med"/>
+                      <a:tailEnd type="none" w="med" len="med"/>
+                    </a:lnT>
+                    <a:lnB w="6350" cap="flat" cmpd="sng" algn="ctr">
+                      <a:solidFill>
+                        <a:srgbClr val="D5DAE1"/>
+                      </a:solidFill>
+                      <a:prstDash val="solid"/>
+                      <a:round/>
+                      <a:headEnd type="none" w="med" len="med"/>
+                      <a:tailEnd type="none" w="med" len="med"/>
+                    </a:lnB>
+                    <a:solidFill>
+                      <a:srgbClr val="F2F4F7"/>
+                    </a:solidFill>
+                  </a:tcPr>
+                </a:tc>
+              </a:tr>
+            </a:tbl>
+          </a:graphicData>
+        </a:graphic>
+      </p:graphicFrame>
+      <p:sp>
+        <p:nvSpPr>
+          <p:cNvPr id="7" name="Text 1"/>
+          <p:cNvSpPr txBox="1"/>
+          <p:nvPr/>
+        </p:nvSpPr>
+        <p:spPr>
+          <a:xfrm>
+            <a:off x="548640" y="5029200"/>
+            <a:ext cx="11064240" cy="1005840"/>
+          </a:xfrm>
+          <a:prstGeom prst="rect">
+            <a:avLst/>
+          </a:prstGeom>
+          <a:noFill/>
+          <a:ln/>
+        </p:spPr>
+        <p:txBody>
+          <a:bodyPr wrap="square" lIns="0" tIns="0" rIns="0" bIns="0" rtlCol="0" anchor="t"/>
+          <a:lstStyle/>
+          <a:p>
+            <a:pPr marL="342900" indent="-342900">
+              <a:spcAft>
+                <a:spcPts val="600"/>
+              </a:spcAft>
+              <a:buSzPct val="100000"/>
+              <a:buChar char="•"/>
+            </a:pPr>
+            <a:r>
+              <a:rPr lang="en-US" sz="1200" dirty="0">
+                <a:solidFill>
+                  <a:srgbClr val="1B1F2A"/>
+                </a:solidFill>
+              </a:rPr>
+              <a:t>Base case: the combined position is lowest at EGP 168.0 million in month 15 and turns positive in month 30.</a:t>
+            </a:r>
+            <a:endParaRPr lang="en-US" sz="1200" dirty="0"/>
+          </a:p>
+          <a:p>
+            <a:pPr marL="342900" indent="-342900">
+              <a:spcAft>
+                <a:spcPts val="600"/>
+              </a:spcAft>
+              <a:buSzPct val="100000"/>
+              <a:buChar char="•"/>
+            </a:pPr>
+            <a:r>
+              <a:rPr lang="en-US" sz="1200" dirty="0">
+                <a:solidFill>
+                  <a:srgbClr val="1B1F2A"/>
+                </a:solidFill>
+              </a:rPr>
+              <a:t>In the stress cases both projects are short at the same time, so one project's cash cannot be assumed to fund the other.</a:t>
+            </a:r>
+            <a:endParaRPr lang="en-US" sz="1200" dirty="0"/>
+          </a:p>
+          <a:p>
+            <a:pPr marL="342900" indent="-342900">
+              <a:spcAft>
+                <a:spcPts val="600"/>
+              </a:spcAft>
+              <a:buSzPct val="100000"/>
+              <a:buChar char="•"/>
+            </a:pPr>
+            <a:r>
+              <a:rPr lang="en-US" sz="1200" dirty="0">
+                <a:solidFill>
+                  <a:srgbClr val="1B1F2A"/>
+                </a:solidFill>
+              </a:rPr>
+              <a:t>Shown: these two projects only, before any investor instrument. Jalour's cash reserves and other projects are not included. No cross-collateral or cross-default between the projects.</a:t>
+            </a:r>
+            <a:endParaRPr lang="en-US" sz="1200" dirty="0"/>
+          </a:p>
+        </p:txBody>
+      </p:sp>
+      <p:sp>
+        <p:nvSpPr>
+          <p:cNvPr id="8" name="Text 2"/>
+          <p:cNvSpPr txBox="1"/>
+          <p:nvPr/>
+        </p:nvSpPr>
+        <p:spPr>
+          <a:xfrm>
+            <a:off x="548640" y="6080760"/>
+            <a:ext cx="11064240" cy="274320"/>
+          </a:xfrm>
+          <a:prstGeom prst="rect">
+            <a:avLst/>
+          </a:prstGeom>
+          <a:noFill/>
+          <a:ln/>
+        </p:spPr>
+        <p:txBody>
+          <a:bodyPr wrap="square" lIns="0" tIns="0" rIns="0" bIns="0" rtlCol="0" anchor="ctr"/>
+          <a:lstStyle/>
+          <a:p>
+            <a:pPr indent="0" marL="0">
+              <a:buNone/>
+            </a:pPr>
+            <a:r>
+              <a:rPr lang="en-US" sz="900" i="1" dirty="0">
+                <a:solidFill>
+                  <a:srgbClr val="6B7280"/>
+                </a:solidFill>
+              </a:rPr>
+              <a:t>Source: Jalour financial model; Financial Annex, Combined_Position sheet. Projections, not guarantees.</a:t>
+            </a:r>
+            <a:endParaRPr lang="en-US" sz="900" dirty="0"/>
+          </a:p>
+        </p:txBody>
+      </p:sp>
+      <p:sp>
+        <p:nvSpPr>
+          <p:cNvPr id="25" name="Slide Number Placeholder 0"/>
+          <p:cNvSpPr>
+            <a:spLocks noGrp="1"/>
+          </p:cNvSpPr>
+          <p:nvPr>
+            <p:ph type="sldNum" sz="quarter" idx="4294967295"/>
+          </p:nvPr>
+        </p:nvSpPr>
+        <p:spPr>
+          <a:xfrm>
+            <a:off x="11155680" y="6446520"/>
+            <a:ext cx="548640" cy="274320"/>
+          </a:xfrm>
+          <a:prstGeom prst="rect">
+            <a:avLst/>
+          </a:prstGeom>
+          <a:extLst>
+            <a:ext uri="{C572A759-6A51-4108-AA02-DFA0A04FC94B}">
+              <ma14:wrappingTextBoxFlag xmlns:ma14="http://schemas.microsoft.com/office/mac/drawingml/2011/main" val="0"/>
+            </a:ext>
+          </a:extLst>
+        </p:spPr>
+        <p:txBody>
+          <a:bodyPr/>
+          <a:lstStyle>
+            <a:lvl1pPr>
+              <a:defRPr sz="900">
+                <a:solidFill>
+                  <a:srgbClr val="6B7280"/>
+                </a:solidFill>
+              </a:defRPr>
+            </a:lvl1pPr>
+          </a:lstStyle>
+          <a:p>
+            <a:pPr algn="l"/>
+            <a:fld id="{F7021451-1387-4CA6-816F-3879F97B5CBC}" type="slidenum">
+              <a:rPr b="0" lang="en-US"/>
+              <a:t>11</a:t>
+            </a:fld>
+            <a:endParaRPr lang="en-US"/>
+          </a:p>
+        </p:txBody>
+      </p:sp>
+    </p:spTree>
+  </p:cSld>
+  <p:clrMapOvr>
+    <a:masterClrMapping/>
+  </p:clrMapOvr>
+</p:sld>
+</file>
+
+<file path=ppt/slides/slide12.xml><?xml version="1.0" encoding="utf-8"?>
+<p:sld xmlns:a="http://schemas.openxmlformats.org/drawingml/2006/main" xmlns:r="http://schemas.openxmlformats.org/officeDocument/2006/relationships" xmlns:p="http://schemas.openxmlformats.org/presentationml/2006/main">
+  <p:cSld name="Slide 12">
+    <p:spTree>
+      <p:nvGrpSpPr>
+        <p:cNvPr id="1" name=""/>
+        <p:cNvGrpSpPr/>
+        <p:nvPr/>
+      </p:nvGrpSpPr>
+      <p:grpSpPr>
+        <a:xfrm>
+          <a:off x="0" y="0"/>
+          <a:ext cx="0" cy="0"/>
+          <a:chOff x="0" y="0"/>
+          <a:chExt cx="0" cy="0"/>
+        </a:xfrm>
+      </p:grpSpPr>
+      <p:sp>
+        <p:nvSpPr>
+          <p:cNvPr id="2" name="Text 0"/>
+          <p:cNvSpPr txBox="1"/>
+          <p:nvPr/>
+        </p:nvSpPr>
+        <p:spPr>
+          <a:xfrm>
+            <a:off x="548640" y="320040"/>
+            <a:ext cx="11064240" cy="822960"/>
+          </a:xfrm>
+          <a:prstGeom prst="rect">
+            <a:avLst/>
+          </a:prstGeom>
+          <a:noFill/>
+          <a:ln/>
+        </p:spPr>
+        <p:txBody>
+          <a:bodyPr wrap="square" lIns="0" tIns="0" rIns="0" bIns="0" rtlCol="0" anchor="ctr">
+            <a:normAutofit/>
+          </a:bodyPr>
+          <a:lstStyle/>
+          <a:p>
+            <a:pPr indent="0" marL="0">
+              <a:buNone/>
+            </a:pPr>
+            <a:r>
+              <a:rPr lang="en-US" sz="2800" b="1" dirty="0">
+                <a:solidFill>
+                  <a:srgbClr val="17324D"/>
+                </a:solidFill>
+                <a:latin typeface="Cambria" pitchFamily="34" charset="0"/>
+                <a:ea typeface="Cambria" pitchFamily="34" charset="-122"/>
+                <a:cs typeface="Cambria" pitchFamily="34" charset="-120"/>
+              </a:rPr>
               <a:t>Sources and uses of funds</a:t>
             </a:r>
             <a:endParaRPr lang="en-US" sz="2800" dirty="0"/>
@@ -5208,7 +8911,7 @@
       </p:sp>
       <p:graphicFrame>
         <p:nvGraphicFramePr>
-          <p:cNvPr id="12" name="Table 0"/>
+          <p:cNvPr id="13" name="Table 0"/>
           <p:cNvGraphicFramePr>
             <a:graphicFrameLocks noGrp="1"/>
           </p:cNvGraphicFramePr>
@@ -5858,7 +9561,7 @@
       </p:graphicFrame>
       <p:graphicFrame>
         <p:nvGraphicFramePr>
-          <p:cNvPr id="23" name="Table 1"/>
+          <p:cNvPr id="25" name="Table 1"/>
           <p:cNvGraphicFramePr>
             <a:graphicFrameLocks noGrp="1"/>
           </p:cNvGraphicFramePr>
@@ -6965,7 +10668,7 @@
             <a:pPr algn="l"/>
             <a:fld id="{F7021451-1387-4CA6-816F-3879F97B5CBC}" type="slidenum">
               <a:rPr b="0" lang="en-US"/>
-              <a:t>11</a:t>
+              <a:t>12</a:t>
             </a:fld>
             <a:endParaRPr lang="en-US"/>
           </a:p>
@@ -6979,9 +10682,9 @@
 </p:sld>
 </file>
 
-<file path=ppt/slides/slide12.xml><?xml version="1.0" encoding="utf-8"?>
+<file path=ppt/slides/slide13.xml><?xml version="1.0" encoding="utf-8"?>
 <p:sld xmlns:a="http://schemas.openxmlformats.org/drawingml/2006/main" xmlns:r="http://schemas.openxmlformats.org/officeDocument/2006/relationships" xmlns:p="http://schemas.openxmlformats.org/presentationml/2006/main">
-  <p:cSld name="Slide 12">
+  <p:cSld name="Slide 13">
     <p:spTree>
       <p:nvGrpSpPr>
         <p:cNvPr id="1" name=""/>
@@ -7039,7 +10742,7 @@
       </p:sp>
       <p:graphicFrame>
         <p:nvGraphicFramePr>
-          <p:cNvPr id="13" name="Table 0"/>
+          <p:cNvPr id="14" name="Table 0"/>
           <p:cNvGraphicFramePr>
             <a:graphicFrameLocks noGrp="1"/>
           </p:cNvGraphicFramePr>
@@ -8985,7 +12688,7 @@
             <a:pPr algn="l"/>
             <a:fld id="{F7021451-1387-4CA6-816F-3879F97B5CBC}" type="slidenum">
               <a:rPr b="0" lang="en-US"/>
-              <a:t>12</a:t>
+              <a:t>13</a:t>
             </a:fld>
             <a:endParaRPr lang="en-US"/>
           </a:p>
@@ -8999,9 +12702,9 @@
 </p:sld>
 </file>
 
-<file path=ppt/slides/slide13.xml><?xml version="1.0" encoding="utf-8"?>
+<file path=ppt/slides/slide14.xml><?xml version="1.0" encoding="utf-8"?>
 <p:sld xmlns:a="http://schemas.openxmlformats.org/drawingml/2006/main" xmlns:r="http://schemas.openxmlformats.org/officeDocument/2006/relationships" xmlns:p="http://schemas.openxmlformats.org/presentationml/2006/main">
-  <p:cSld name="Slide 13">
+  <p:cSld name="Slide 14">
     <p:spTree>
       <p:nvGrpSpPr>
         <p:cNvPr id="1" name=""/>
@@ -9496,7 +13199,7 @@
             <a:pPr algn="l"/>
             <a:fld id="{F7021451-1387-4CA6-816F-3879F97B5CBC}" type="slidenum">
               <a:rPr b="0" lang="en-US"/>
-              <a:t>13</a:t>
+              <a:t>14</a:t>
             </a:fld>
             <a:endParaRPr lang="en-US"/>
           </a:p>
@@ -9510,9 +13213,9 @@
 </p:sld>
 </file>
 
-<file path=ppt/slides/slide14.xml><?xml version="1.0" encoding="utf-8"?>
+<file path=ppt/slides/slide15.xml><?xml version="1.0" encoding="utf-8"?>
 <p:sld xmlns:a="http://schemas.openxmlformats.org/drawingml/2006/main" xmlns:r="http://schemas.openxmlformats.org/officeDocument/2006/relationships" xmlns:p="http://schemas.openxmlformats.org/presentationml/2006/main">
-  <p:cSld name="Slide 14">
+  <p:cSld name="Slide 15">
     <p:spTree>
       <p:nvGrpSpPr>
         <p:cNvPr id="1" name=""/>
@@ -9586,7 +13289,7 @@
       </p:graphicFrame>
       <p:graphicFrame>
         <p:nvGraphicFramePr>
-          <p:cNvPr id="15" name="Table 0"/>
+          <p:cNvPr id="16" name="Table 0"/>
           <p:cNvGraphicFramePr>
             <a:graphicFrameLocks noGrp="1"/>
           </p:cNvGraphicFramePr>
@@ -11246,7 +14949,7 @@
             <a:pPr algn="l"/>
             <a:fld id="{F7021451-1387-4CA6-816F-3879F97B5CBC}" type="slidenum">
               <a:rPr b="0" lang="en-US"/>
-              <a:t>14</a:t>
+              <a:t>15</a:t>
             </a:fld>
             <a:endParaRPr lang="en-US"/>
           </a:p>
@@ -11260,9 +14963,9 @@
 </p:sld>
 </file>
 
-<file path=ppt/slides/slide15.xml><?xml version="1.0" encoding="utf-8"?>
+<file path=ppt/slides/slide16.xml><?xml version="1.0" encoding="utf-8"?>
 <p:sld xmlns:a="http://schemas.openxmlformats.org/drawingml/2006/main" xmlns:r="http://schemas.openxmlformats.org/officeDocument/2006/relationships" xmlns:p="http://schemas.openxmlformats.org/presentationml/2006/main">
-  <p:cSld name="Slide 15">
+  <p:cSld name="Slide 16">
     <p:spTree>
       <p:nvGrpSpPr>
         <p:cNvPr id="1" name=""/>
@@ -11320,7 +15023,7 @@
       </p:sp>
       <p:graphicFrame>
         <p:nvGraphicFramePr>
-          <p:cNvPr id="16" name="Table 0"/>
+          <p:cNvPr id="17" name="Table 0"/>
           <p:cNvGraphicFramePr>
             <a:graphicFrameLocks noGrp="1"/>
           </p:cNvGraphicFramePr>
@@ -12539,7 +16242,7 @@
             <a:pPr algn="l"/>
             <a:fld id="{F7021451-1387-4CA6-816F-3879F97B5CBC}" type="slidenum">
               <a:rPr b="0" lang="en-US"/>
-              <a:t>15</a:t>
+              <a:t>16</a:t>
             </a:fld>
             <a:endParaRPr lang="en-US"/>
           </a:p>
@@ -12553,9 +16256,9 @@
 </p:sld>
 </file>
 
-<file path=ppt/slides/slide16.xml><?xml version="1.0" encoding="utf-8"?>
+<file path=ppt/slides/slide17.xml><?xml version="1.0" encoding="utf-8"?>
 <p:sld xmlns:a="http://schemas.openxmlformats.org/drawingml/2006/main" xmlns:r="http://schemas.openxmlformats.org/officeDocument/2006/relationships" xmlns:p="http://schemas.openxmlformats.org/presentationml/2006/main">
-  <p:cSld name="Slide 16">
+  <p:cSld name="Slide 17">
     <p:spTree>
       <p:nvGrpSpPr>
         <p:cNvPr id="1" name=""/>
@@ -13385,7 +17088,7 @@
             <a:pPr algn="l"/>
             <a:fld id="{F7021451-1387-4CA6-816F-3879F97B5CBC}" type="slidenum">
               <a:rPr b="0" lang="en-US"/>
-              <a:t>16</a:t>
+              <a:t>17</a:t>
             </a:fld>
             <a:endParaRPr lang="en-US"/>
           </a:p>
@@ -13399,9 +17102,9 @@
 </p:sld>
 </file>
 
-<file path=ppt/slides/slide17.xml><?xml version="1.0" encoding="utf-8"?>
+<file path=ppt/slides/slide18.xml><?xml version="1.0" encoding="utf-8"?>
 <p:sld xmlns:a="http://schemas.openxmlformats.org/drawingml/2006/main" xmlns:r="http://schemas.openxmlformats.org/officeDocument/2006/relationships" xmlns:p="http://schemas.openxmlformats.org/presentationml/2006/main">
-  <p:cSld name="Slide 17">
+  <p:cSld name="Slide 18">
     <p:spTree>
       <p:nvGrpSpPr>
         <p:cNvPr id="1" name=""/>
@@ -18043,7 +21746,7 @@
                   <a:srgbClr val="1B1F2A"/>
                 </a:solidFill>
               </a:rPr>
-              <a:t>Reading across: the sales plan needs price growth that sits at the upper end of recent evidence. The downside case on slide 14 tests lower prices and later sales.</a:t>
+              <a:t>Reading across: the sales plan needs price growth that sits at the upper end of recent evidence. The downside case on slide 15 tests lower prices and later sales.</a:t>
             </a:r>
             <a:endParaRPr lang="en-US" sz="1300" dirty="0"/>
           </a:p>

</xml_diff>